<commit_message>
Admin: change frontend templates : [SystemNameSmall]-main to [SystemNameSmall]/main. Add religion image. @"C:\Bfs_V1\V2";
</commit_message>
<xml_diff>
--- a/Admin/_Documents/Docs.pptx
+++ b/Admin/_Documents/Docs.pptx
@@ -19,29 +19,30 @@
     <p:sldId id="274" r:id="rId13"/>
     <p:sldId id="279" r:id="rId14"/>
     <p:sldId id="282" r:id="rId15"/>
-    <p:sldId id="275" r:id="rId16"/>
-    <p:sldId id="281" r:id="rId17"/>
-    <p:sldId id="272" r:id="rId18"/>
-    <p:sldId id="276" r:id="rId19"/>
-    <p:sldId id="278" r:id="rId20"/>
-    <p:sldId id="270" r:id="rId21"/>
-    <p:sldId id="271" r:id="rId22"/>
-    <p:sldId id="280" r:id="rId23"/>
-    <p:sldId id="277" r:id="rId24"/>
-    <p:sldId id="256" r:id="rId25"/>
-    <p:sldId id="257" r:id="rId26"/>
-    <p:sldId id="258" r:id="rId27"/>
-    <p:sldId id="259" r:id="rId28"/>
-    <p:sldId id="260" r:id="rId29"/>
-    <p:sldId id="261" r:id="rId30"/>
-    <p:sldId id="265" r:id="rId31"/>
-    <p:sldId id="283" r:id="rId32"/>
-    <p:sldId id="284" r:id="rId33"/>
-    <p:sldId id="285" r:id="rId34"/>
-    <p:sldId id="286" r:id="rId35"/>
-    <p:sldId id="287" r:id="rId36"/>
-    <p:sldId id="288" r:id="rId37"/>
-    <p:sldId id="289" r:id="rId38"/>
+    <p:sldId id="293" r:id="rId16"/>
+    <p:sldId id="275" r:id="rId17"/>
+    <p:sldId id="281" r:id="rId18"/>
+    <p:sldId id="272" r:id="rId19"/>
+    <p:sldId id="276" r:id="rId20"/>
+    <p:sldId id="278" r:id="rId21"/>
+    <p:sldId id="270" r:id="rId22"/>
+    <p:sldId id="271" r:id="rId23"/>
+    <p:sldId id="280" r:id="rId24"/>
+    <p:sldId id="277" r:id="rId25"/>
+    <p:sldId id="256" r:id="rId26"/>
+    <p:sldId id="257" r:id="rId27"/>
+    <p:sldId id="258" r:id="rId28"/>
+    <p:sldId id="259" r:id="rId29"/>
+    <p:sldId id="260" r:id="rId30"/>
+    <p:sldId id="261" r:id="rId31"/>
+    <p:sldId id="265" r:id="rId32"/>
+    <p:sldId id="283" r:id="rId33"/>
+    <p:sldId id="284" r:id="rId34"/>
+    <p:sldId id="285" r:id="rId35"/>
+    <p:sldId id="286" r:id="rId36"/>
+    <p:sldId id="287" r:id="rId37"/>
+    <p:sldId id="288" r:id="rId38"/>
+    <p:sldId id="289" r:id="rId39"/>
   </p:sldIdLst>
   <p:sldSz cx="12192000" cy="6858000"/>
   <p:notesSz cx="6858000" cy="9144000"/>
@@ -295,7 +296,7 @@
           <a:p>
             <a:fld id="{5AD74501-8691-4646-B472-1139202FB98B}" type="datetimeFigureOut">
               <a:rPr lang="en-US" smtClean="0"/>
-              <a:t>8/2/2026</a:t>
+              <a:t>9/26/2026</a:t>
             </a:fld>
             <a:endParaRPr lang="en-US"/>
           </a:p>
@@ -493,7 +494,7 @@
           <a:p>
             <a:fld id="{5AD74501-8691-4646-B472-1139202FB98B}" type="datetimeFigureOut">
               <a:rPr lang="en-US" smtClean="0"/>
-              <a:t>8/2/2026</a:t>
+              <a:t>9/26/2026</a:t>
             </a:fld>
             <a:endParaRPr lang="en-US"/>
           </a:p>
@@ -701,7 +702,7 @@
           <a:p>
             <a:fld id="{5AD74501-8691-4646-B472-1139202FB98B}" type="datetimeFigureOut">
               <a:rPr lang="en-US" smtClean="0"/>
-              <a:t>8/2/2026</a:t>
+              <a:t>9/26/2026</a:t>
             </a:fld>
             <a:endParaRPr lang="en-US"/>
           </a:p>
@@ -899,7 +900,7 @@
           <a:p>
             <a:fld id="{5AD74501-8691-4646-B472-1139202FB98B}" type="datetimeFigureOut">
               <a:rPr lang="en-US" smtClean="0"/>
-              <a:t>8/2/2026</a:t>
+              <a:t>9/26/2026</a:t>
             </a:fld>
             <a:endParaRPr lang="en-US"/>
           </a:p>
@@ -1174,7 +1175,7 @@
           <a:p>
             <a:fld id="{5AD74501-8691-4646-B472-1139202FB98B}" type="datetimeFigureOut">
               <a:rPr lang="en-US" smtClean="0"/>
-              <a:t>8/2/2026</a:t>
+              <a:t>9/26/2026</a:t>
             </a:fld>
             <a:endParaRPr lang="en-US"/>
           </a:p>
@@ -1439,7 +1440,7 @@
           <a:p>
             <a:fld id="{5AD74501-8691-4646-B472-1139202FB98B}" type="datetimeFigureOut">
               <a:rPr lang="en-US" smtClean="0"/>
-              <a:t>8/2/2026</a:t>
+              <a:t>9/26/2026</a:t>
             </a:fld>
             <a:endParaRPr lang="en-US"/>
           </a:p>
@@ -1851,7 +1852,7 @@
           <a:p>
             <a:fld id="{5AD74501-8691-4646-B472-1139202FB98B}" type="datetimeFigureOut">
               <a:rPr lang="en-US" smtClean="0"/>
-              <a:t>8/2/2026</a:t>
+              <a:t>9/26/2026</a:t>
             </a:fld>
             <a:endParaRPr lang="en-US"/>
           </a:p>
@@ -1992,7 +1993,7 @@
           <a:p>
             <a:fld id="{5AD74501-8691-4646-B472-1139202FB98B}" type="datetimeFigureOut">
               <a:rPr lang="en-US" smtClean="0"/>
-              <a:t>8/2/2026</a:t>
+              <a:t>9/26/2026</a:t>
             </a:fld>
             <a:endParaRPr lang="en-US"/>
           </a:p>
@@ -2105,7 +2106,7 @@
           <a:p>
             <a:fld id="{5AD74501-8691-4646-B472-1139202FB98B}" type="datetimeFigureOut">
               <a:rPr lang="en-US" smtClean="0"/>
-              <a:t>8/2/2026</a:t>
+              <a:t>9/26/2026</a:t>
             </a:fld>
             <a:endParaRPr lang="en-US"/>
           </a:p>
@@ -2416,7 +2417,7 @@
           <a:p>
             <a:fld id="{5AD74501-8691-4646-B472-1139202FB98B}" type="datetimeFigureOut">
               <a:rPr lang="en-US" smtClean="0"/>
-              <a:t>8/2/2026</a:t>
+              <a:t>9/26/2026</a:t>
             </a:fld>
             <a:endParaRPr lang="en-US"/>
           </a:p>
@@ -2704,7 +2705,7 @@
           <a:p>
             <a:fld id="{5AD74501-8691-4646-B472-1139202FB98B}" type="datetimeFigureOut">
               <a:rPr lang="en-US" smtClean="0"/>
-              <a:t>8/2/2026</a:t>
+              <a:t>9/26/2026</a:t>
             </a:fld>
             <a:endParaRPr lang="en-US"/>
           </a:p>
@@ -2945,7 +2946,7 @@
           <a:p>
             <a:fld id="{5AD74501-8691-4646-B472-1139202FB98B}" type="datetimeFigureOut">
               <a:rPr lang="en-US" smtClean="0"/>
-              <a:t>8/2/2026</a:t>
+              <a:t>9/26/2026</a:t>
             </a:fld>
             <a:endParaRPr lang="en-US"/>
           </a:p>
@@ -6105,6 +6106,294 @@
         <p:cNvPr id="1" name="">
           <a:extLst>
             <a:ext uri="{FF2B5EF4-FFF2-40B4-BE49-F238E27FC236}">
+              <a16:creationId xmlns:a16="http://schemas.microsoft.com/office/drawing/2014/main" id="{5057D02B-112E-90FE-C2A0-3FBCCA00FC39}"/>
+            </a:ext>
+          </a:extLst>
+        </p:cNvPr>
+        <p:cNvGrpSpPr/>
+        <p:nvPr/>
+      </p:nvGrpSpPr>
+      <p:grpSpPr>
+        <a:xfrm>
+          <a:off x="0" y="0"/>
+          <a:ext cx="0" cy="0"/>
+          <a:chOff x="0" y="0"/>
+          <a:chExt cx="0" cy="0"/>
+        </a:xfrm>
+      </p:grpSpPr>
+      <p:sp>
+        <p:nvSpPr>
+          <p:cNvPr id="2" name="Freeform: Shape 1">
+            <a:extLst>
+              <a:ext uri="{FF2B5EF4-FFF2-40B4-BE49-F238E27FC236}">
+                <a16:creationId xmlns:a16="http://schemas.microsoft.com/office/drawing/2014/main" id="{C4A80704-401E-F5B2-7DCE-F56B42A3CBE0}"/>
+              </a:ext>
+            </a:extLst>
+          </p:cNvPr>
+          <p:cNvSpPr/>
+          <p:nvPr/>
+        </p:nvSpPr>
+        <p:spPr>
+          <a:xfrm>
+            <a:off x="3003618" y="552917"/>
+            <a:ext cx="7229138" cy="6228674"/>
+          </a:xfrm>
+          <a:custGeom>
+            <a:avLst/>
+            <a:gdLst>
+              <a:gd name="csX0" fmla="*/ -1 w 7229138"/>
+              <a:gd name="csY0" fmla="*/ 3114376 h 6228674"/>
+              <a:gd name="csX1" fmla="*/ 3614568 w 7229138"/>
+              <a:gd name="csY1" fmla="*/ 40 h 6228674"/>
+              <a:gd name="csX2" fmla="*/ 7229137 w 7229138"/>
+              <a:gd name="csY2" fmla="*/ 3114376 h 6228674"/>
+              <a:gd name="csX3" fmla="*/ 3614568 w 7229138"/>
+              <a:gd name="csY3" fmla="*/ 6228715 h 6228674"/>
+              <a:gd name="csX4" fmla="*/ -1 w 7229138"/>
+              <a:gd name="csY4" fmla="*/ 3114376 h 6228674"/>
+            </a:gdLst>
+            <a:ahLst/>
+            <a:cxnLst>
+              <a:cxn ang="0">
+                <a:pos x="csX0" y="csY0"/>
+              </a:cxn>
+              <a:cxn ang="0">
+                <a:pos x="csX1" y="csY1"/>
+              </a:cxn>
+              <a:cxn ang="0">
+                <a:pos x="csX2" y="csY2"/>
+              </a:cxn>
+              <a:cxn ang="0">
+                <a:pos x="csX3" y="csY3"/>
+              </a:cxn>
+              <a:cxn ang="0">
+                <a:pos x="csX4" y="csY4"/>
+              </a:cxn>
+            </a:cxnLst>
+            <a:rect l="l" t="t" r="r" b="b"/>
+            <a:pathLst>
+              <a:path w="7229138" h="6228674">
+                <a:moveTo>
+                  <a:pt x="-1" y="3114376"/>
+                </a:moveTo>
+                <a:cubicBezTo>
+                  <a:pt x="-1" y="1394373"/>
+                  <a:pt x="1618301" y="40"/>
+                  <a:pt x="3614568" y="40"/>
+                </a:cubicBezTo>
+                <a:cubicBezTo>
+                  <a:pt x="5610843" y="40"/>
+                  <a:pt x="7229137" y="1394373"/>
+                  <a:pt x="7229137" y="3114376"/>
+                </a:cubicBezTo>
+                <a:cubicBezTo>
+                  <a:pt x="7229137" y="4834378"/>
+                  <a:pt x="5610843" y="6228715"/>
+                  <a:pt x="3614568" y="6228715"/>
+                </a:cubicBezTo>
+                <a:cubicBezTo>
+                  <a:pt x="1618301" y="6228715"/>
+                  <a:pt x="-1" y="4834378"/>
+                  <a:pt x="-1" y="3114376"/>
+                </a:cubicBezTo>
+                <a:close/>
+              </a:path>
+            </a:pathLst>
+          </a:custGeom>
+          <a:solidFill>
+            <a:srgbClr val="4472C4">
+              <a:alpha val="15000"/>
+            </a:srgbClr>
+          </a:solidFill>
+          <a:ln w="8067" cap="flat">
+            <a:noFill/>
+            <a:prstDash val="solid"/>
+            <a:miter/>
+          </a:ln>
+        </p:spPr>
+        <p:txBody>
+          <a:bodyPr/>
+          <a:lstStyle/>
+          <a:p>
+            <a:endParaRPr lang="en-US"/>
+          </a:p>
+        </p:txBody>
+      </p:sp>
+      <p:sp>
+        <p:nvSpPr>
+          <p:cNvPr id="9" name="Freeform: Shape 8">
+            <a:extLst>
+              <a:ext uri="{FF2B5EF4-FFF2-40B4-BE49-F238E27FC236}">
+                <a16:creationId xmlns:a16="http://schemas.microsoft.com/office/drawing/2014/main" id="{BF77E3F6-02D6-AE66-C8C8-F64A367D6B94}"/>
+              </a:ext>
+            </a:extLst>
+          </p:cNvPr>
+          <p:cNvSpPr/>
+          <p:nvPr/>
+        </p:nvSpPr>
+        <p:spPr>
+          <a:xfrm>
+            <a:off x="3003618" y="72185"/>
+            <a:ext cx="7229139" cy="6228677"/>
+          </a:xfrm>
+          <a:custGeom>
+            <a:avLst/>
+            <a:gdLst>
+              <a:gd name="csX0" fmla="*/ -1371 w 7229139"/>
+              <a:gd name="csY0" fmla="*/ 3112940 h 6228677"/>
+              <a:gd name="csX1" fmla="*/ 3613199 w 7229139"/>
+              <a:gd name="csY1" fmla="*/ -1399 h 6228677"/>
+              <a:gd name="csX2" fmla="*/ 7227768 w 7229139"/>
+              <a:gd name="csY2" fmla="*/ 3112940 h 6228677"/>
+              <a:gd name="csX3" fmla="*/ 3613199 w 7229139"/>
+              <a:gd name="csY3" fmla="*/ 6227279 h 6228677"/>
+              <a:gd name="csX4" fmla="*/ -1371 w 7229139"/>
+              <a:gd name="csY4" fmla="*/ 3112940 h 6228677"/>
+            </a:gdLst>
+            <a:ahLst/>
+            <a:cxnLst>
+              <a:cxn ang="0">
+                <a:pos x="csX0" y="csY0"/>
+              </a:cxn>
+              <a:cxn ang="0">
+                <a:pos x="csX1" y="csY1"/>
+              </a:cxn>
+              <a:cxn ang="0">
+                <a:pos x="csX2" y="csY2"/>
+              </a:cxn>
+              <a:cxn ang="0">
+                <a:pos x="csX3" y="csY3"/>
+              </a:cxn>
+              <a:cxn ang="0">
+                <a:pos x="csX4" y="csY4"/>
+              </a:cxn>
+            </a:cxnLst>
+            <a:rect l="l" t="t" r="r" b="b"/>
+            <a:pathLst>
+              <a:path w="7229139" h="6228677">
+                <a:moveTo>
+                  <a:pt x="-1371" y="3112940"/>
+                </a:moveTo>
+                <a:cubicBezTo>
+                  <a:pt x="-1371" y="1392953"/>
+                  <a:pt x="1616955" y="-1399"/>
+                  <a:pt x="3613199" y="-1399"/>
+                </a:cubicBezTo>
+                <a:cubicBezTo>
+                  <a:pt x="5609441" y="-1399"/>
+                  <a:pt x="7227768" y="1392953"/>
+                  <a:pt x="7227768" y="3112940"/>
+                </a:cubicBezTo>
+                <a:cubicBezTo>
+                  <a:pt x="7227768" y="4832927"/>
+                  <a:pt x="5609441" y="6227279"/>
+                  <a:pt x="3613199" y="6227279"/>
+                </a:cubicBezTo>
+                <a:cubicBezTo>
+                  <a:pt x="1616955" y="6227279"/>
+                  <a:pt x="-1371" y="4832927"/>
+                  <a:pt x="-1371" y="3112940"/>
+                </a:cubicBezTo>
+                <a:close/>
+              </a:path>
+            </a:pathLst>
+          </a:custGeom>
+          <a:solidFill>
+            <a:srgbClr val="4472C4">
+              <a:alpha val="15000"/>
+            </a:srgbClr>
+          </a:solidFill>
+          <a:ln w="8067" cap="flat">
+            <a:noFill/>
+            <a:prstDash val="solid"/>
+            <a:miter/>
+          </a:ln>
+        </p:spPr>
+        <p:txBody>
+          <a:bodyPr/>
+          <a:lstStyle/>
+          <a:p>
+            <a:endParaRPr lang="en-US"/>
+          </a:p>
+        </p:txBody>
+      </p:sp>
+      <p:sp>
+        <p:nvSpPr>
+          <p:cNvPr id="3" name="Cross 2">
+            <a:extLst>
+              <a:ext uri="{FF2B5EF4-FFF2-40B4-BE49-F238E27FC236}">
+                <a16:creationId xmlns:a16="http://schemas.microsoft.com/office/drawing/2014/main" id="{69E6C2E4-5ABA-D91A-8DFE-446A3940E168}"/>
+              </a:ext>
+            </a:extLst>
+          </p:cNvPr>
+          <p:cNvSpPr/>
+          <p:nvPr/>
+        </p:nvSpPr>
+        <p:spPr>
+          <a:xfrm>
+            <a:off x="4251720" y="1014984"/>
+            <a:ext cx="4732934" cy="4828032"/>
+          </a:xfrm>
+          <a:prstGeom prst="plus">
+            <a:avLst>
+              <a:gd name="adj" fmla="val 40224"/>
+            </a:avLst>
+          </a:prstGeom>
+          <a:solidFill>
+            <a:schemeClr val="accent1">
+              <a:alpha val="35000"/>
+            </a:schemeClr>
+          </a:solidFill>
+          <a:ln>
+            <a:noFill/>
+          </a:ln>
+        </p:spPr>
+        <p:style>
+          <a:lnRef idx="2">
+            <a:schemeClr val="accent1">
+              <a:shade val="15000"/>
+            </a:schemeClr>
+          </a:lnRef>
+          <a:fillRef idx="1">
+            <a:schemeClr val="accent1"/>
+          </a:fillRef>
+          <a:effectRef idx="0">
+            <a:schemeClr val="accent1"/>
+          </a:effectRef>
+          <a:fontRef idx="minor">
+            <a:schemeClr val="lt1"/>
+          </a:fontRef>
+        </p:style>
+        <p:txBody>
+          <a:bodyPr rtlCol="0" anchor="ctr"/>
+          <a:lstStyle/>
+          <a:p>
+            <a:pPr algn="ctr"/>
+            <a:endParaRPr lang="en-US"/>
+          </a:p>
+        </p:txBody>
+      </p:sp>
+    </p:spTree>
+    <p:extLst>
+      <p:ext uri="{BB962C8B-B14F-4D97-AF65-F5344CB8AC3E}">
+        <p14:creationId xmlns:p14="http://schemas.microsoft.com/office/powerpoint/2010/main" val="4024137123"/>
+      </p:ext>
+    </p:extLst>
+  </p:cSld>
+  <p:clrMapOvr>
+    <a:masterClrMapping/>
+  </p:clrMapOvr>
+</p:sld>
+</file>
+
+<file path=ppt/slides/slide16.xml><?xml version="1.0" encoding="utf-8"?>
+<p:sld xmlns:a="http://schemas.openxmlformats.org/drawingml/2006/main" xmlns:r="http://schemas.openxmlformats.org/officeDocument/2006/relationships" xmlns:p="http://schemas.openxmlformats.org/presentationml/2006/main">
+  <p:cSld>
+    <p:spTree>
+      <p:nvGrpSpPr>
+        <p:cNvPr id="1" name="">
+          <a:extLst>
+            <a:ext uri="{FF2B5EF4-FFF2-40B4-BE49-F238E27FC236}">
               <a16:creationId xmlns:a16="http://schemas.microsoft.com/office/drawing/2014/main" id="{2E5454BD-7283-5076-92AE-BAFE5D9F505A}"/>
             </a:ext>
           </a:extLst>
@@ -6393,7 +6682,7 @@
 </p:sld>
 </file>
 
-<file path=ppt/slides/slide16.xml><?xml version="1.0" encoding="utf-8"?>
+<file path=ppt/slides/slide17.xml><?xml version="1.0" encoding="utf-8"?>
 <p:sld xmlns:a="http://schemas.openxmlformats.org/drawingml/2006/main" xmlns:r="http://schemas.openxmlformats.org/officeDocument/2006/relationships" xmlns:p="http://schemas.openxmlformats.org/presentationml/2006/main">
   <p:cSld>
     <p:spTree>
@@ -6691,7 +6980,7 @@
 </p:sld>
 </file>
 
-<file path=ppt/slides/slide17.xml><?xml version="1.0" encoding="utf-8"?>
+<file path=ppt/slides/slide18.xml><?xml version="1.0" encoding="utf-8"?>
 <p:sld xmlns:a="http://schemas.openxmlformats.org/drawingml/2006/main" xmlns:r="http://schemas.openxmlformats.org/officeDocument/2006/relationships" xmlns:p="http://schemas.openxmlformats.org/presentationml/2006/main">
   <p:cSld>
     <p:spTree>
@@ -6989,7 +7278,7 @@
 </p:sld>
 </file>
 
-<file path=ppt/slides/slide18.xml><?xml version="1.0" encoding="utf-8"?>
+<file path=ppt/slides/slide19.xml><?xml version="1.0" encoding="utf-8"?>
 <p:sld xmlns:a="http://schemas.openxmlformats.org/drawingml/2006/main" xmlns:r="http://schemas.openxmlformats.org/officeDocument/2006/relationships" xmlns:p="http://schemas.openxmlformats.org/presentationml/2006/main">
   <p:cSld>
     <p:spTree>
@@ -7285,7 +7574,1439 @@
 </p:sld>
 </file>
 
-<file path=ppt/slides/slide19.xml><?xml version="1.0" encoding="utf-8"?>
+<file path=ppt/slides/slide2.xml><?xml version="1.0" encoding="utf-8"?>
+<p:sld xmlns:a="http://schemas.openxmlformats.org/drawingml/2006/main" xmlns:r="http://schemas.openxmlformats.org/officeDocument/2006/relationships" xmlns:p="http://schemas.openxmlformats.org/presentationml/2006/main">
+  <p:cSld>
+    <p:spTree>
+      <p:nvGrpSpPr>
+        <p:cNvPr id="1" name=""/>
+        <p:cNvGrpSpPr/>
+        <p:nvPr/>
+      </p:nvGrpSpPr>
+      <p:grpSpPr>
+        <a:xfrm>
+          <a:off x="0" y="0"/>
+          <a:ext cx="0" cy="0"/>
+          <a:chOff x="0" y="0"/>
+          <a:chExt cx="0" cy="0"/>
+        </a:xfrm>
+      </p:grpSpPr>
+      <p:sp>
+        <p:nvSpPr>
+          <p:cNvPr id="14" name="Rectangle 13">
+            <a:extLst>
+              <a:ext uri="{FF2B5EF4-FFF2-40B4-BE49-F238E27FC236}">
+                <a16:creationId xmlns:a16="http://schemas.microsoft.com/office/drawing/2014/main" id="{8DD21041-9BF6-0D90-0159-1E9C2CC5D860}"/>
+              </a:ext>
+            </a:extLst>
+          </p:cNvPr>
+          <p:cNvSpPr/>
+          <p:nvPr/>
+        </p:nvSpPr>
+        <p:spPr>
+          <a:xfrm>
+            <a:off x="271387" y="263345"/>
+            <a:ext cx="10461812" cy="985498"/>
+          </a:xfrm>
+          <a:prstGeom prst="rect">
+            <a:avLst/>
+          </a:prstGeom>
+          <a:solidFill>
+            <a:schemeClr val="bg1">
+              <a:lumMod val="85000"/>
+              <a:alpha val="47000"/>
+            </a:schemeClr>
+          </a:solidFill>
+        </p:spPr>
+        <p:style>
+          <a:lnRef idx="2">
+            <a:schemeClr val="accent1">
+              <a:shade val="15000"/>
+            </a:schemeClr>
+          </a:lnRef>
+          <a:fillRef idx="1">
+            <a:schemeClr val="accent1"/>
+          </a:fillRef>
+          <a:effectRef idx="0">
+            <a:schemeClr val="accent1"/>
+          </a:effectRef>
+          <a:fontRef idx="minor">
+            <a:schemeClr val="lt1"/>
+          </a:fontRef>
+        </p:style>
+        <p:txBody>
+          <a:bodyPr rtlCol="0" anchor="ctr"/>
+          <a:lstStyle/>
+          <a:p>
+            <a:r>
+              <a:rPr lang="en-AU" dirty="0" err="1">
+                <a:solidFill>
+                  <a:schemeClr val="tx2"/>
+                </a:solidFill>
+              </a:rPr>
+              <a:t>BestFit</a:t>
+            </a:r>
+            <a:endParaRPr lang="en-US" dirty="0">
+              <a:solidFill>
+                <a:schemeClr val="tx2"/>
+              </a:solidFill>
+            </a:endParaRPr>
+          </a:p>
+        </p:txBody>
+      </p:sp>
+      <p:sp>
+        <p:nvSpPr>
+          <p:cNvPr id="12" name="Rectangle 11">
+            <a:extLst>
+              <a:ext uri="{FF2B5EF4-FFF2-40B4-BE49-F238E27FC236}">
+                <a16:creationId xmlns:a16="http://schemas.microsoft.com/office/drawing/2014/main" id="{8030EC64-EF9A-BF48-4413-6599A8DCD81B}"/>
+              </a:ext>
+            </a:extLst>
+          </p:cNvPr>
+          <p:cNvSpPr/>
+          <p:nvPr/>
+        </p:nvSpPr>
+        <p:spPr>
+          <a:xfrm>
+            <a:off x="340659" y="1650125"/>
+            <a:ext cx="10461812" cy="2386166"/>
+          </a:xfrm>
+          <a:prstGeom prst="rect">
+            <a:avLst/>
+          </a:prstGeom>
+          <a:solidFill>
+            <a:schemeClr val="accent1">
+              <a:alpha val="47000"/>
+            </a:schemeClr>
+          </a:solidFill>
+        </p:spPr>
+        <p:style>
+          <a:lnRef idx="2">
+            <a:schemeClr val="accent1">
+              <a:shade val="15000"/>
+            </a:schemeClr>
+          </a:lnRef>
+          <a:fillRef idx="1">
+            <a:schemeClr val="accent1"/>
+          </a:fillRef>
+          <a:effectRef idx="0">
+            <a:schemeClr val="accent1"/>
+          </a:effectRef>
+          <a:fontRef idx="minor">
+            <a:schemeClr val="lt1"/>
+          </a:fontRef>
+        </p:style>
+        <p:txBody>
+          <a:bodyPr rtlCol="0" anchor="ctr"/>
+          <a:lstStyle/>
+          <a:p>
+            <a:r>
+              <a:rPr lang="en-AU" dirty="0"/>
+              <a:t>Tenant</a:t>
+            </a:r>
+            <a:endParaRPr lang="en-US" dirty="0"/>
+          </a:p>
+        </p:txBody>
+      </p:sp>
+      <p:sp>
+        <p:nvSpPr>
+          <p:cNvPr id="5" name="Rectangle: Rounded Corners 4">
+            <a:extLst>
+              <a:ext uri="{FF2B5EF4-FFF2-40B4-BE49-F238E27FC236}">
+                <a16:creationId xmlns:a16="http://schemas.microsoft.com/office/drawing/2014/main" id="{333B4AA0-B3A0-58D3-C3A0-E4A3840A070D}"/>
+              </a:ext>
+            </a:extLst>
+          </p:cNvPr>
+          <p:cNvSpPr/>
+          <p:nvPr/>
+        </p:nvSpPr>
+        <p:spPr>
+          <a:xfrm>
+            <a:off x="7943030" y="377953"/>
+            <a:ext cx="2333296" cy="735726"/>
+          </a:xfrm>
+          <a:prstGeom prst="roundRect">
+            <a:avLst/>
+          </a:prstGeom>
+          <a:solidFill>
+            <a:schemeClr val="bg1">
+              <a:lumMod val="85000"/>
+              <a:alpha val="21000"/>
+            </a:schemeClr>
+          </a:solidFill>
+        </p:spPr>
+        <p:style>
+          <a:lnRef idx="2">
+            <a:schemeClr val="accent1">
+              <a:shade val="15000"/>
+            </a:schemeClr>
+          </a:lnRef>
+          <a:fillRef idx="1">
+            <a:schemeClr val="accent1"/>
+          </a:fillRef>
+          <a:effectRef idx="0">
+            <a:schemeClr val="accent1"/>
+          </a:effectRef>
+          <a:fontRef idx="minor">
+            <a:schemeClr val="lt1"/>
+          </a:fontRef>
+        </p:style>
+        <p:txBody>
+          <a:bodyPr rtlCol="0" anchor="ctr"/>
+          <a:lstStyle/>
+          <a:p>
+            <a:pPr algn="ctr"/>
+            <a:r>
+              <a:rPr lang="en-AU" sz="1600" dirty="0" err="1">
+                <a:solidFill>
+                  <a:schemeClr val="tx1"/>
+                </a:solidFill>
+              </a:rPr>
+              <a:t>BfsSystem</a:t>
+            </a:r>
+            <a:endParaRPr lang="en-US" sz="1600" dirty="0">
+              <a:solidFill>
+                <a:schemeClr val="tx1"/>
+              </a:solidFill>
+            </a:endParaRPr>
+          </a:p>
+        </p:txBody>
+      </p:sp>
+      <p:sp>
+        <p:nvSpPr>
+          <p:cNvPr id="7" name="Rectangle: Rounded Corners 6">
+            <a:extLst>
+              <a:ext uri="{FF2B5EF4-FFF2-40B4-BE49-F238E27FC236}">
+                <a16:creationId xmlns:a16="http://schemas.microsoft.com/office/drawing/2014/main" id="{EB30A78B-1428-398F-0328-F280D80AE345}"/>
+              </a:ext>
+            </a:extLst>
+          </p:cNvPr>
+          <p:cNvSpPr/>
+          <p:nvPr/>
+        </p:nvSpPr>
+        <p:spPr>
+          <a:xfrm>
+            <a:off x="8210884" y="1833058"/>
+            <a:ext cx="1801334" cy="392906"/>
+          </a:xfrm>
+          <a:prstGeom prst="roundRect">
+            <a:avLst/>
+          </a:prstGeom>
+          <a:solidFill>
+            <a:schemeClr val="accent1">
+              <a:alpha val="21000"/>
+            </a:schemeClr>
+          </a:solidFill>
+        </p:spPr>
+        <p:style>
+          <a:lnRef idx="2">
+            <a:schemeClr val="accent1">
+              <a:shade val="15000"/>
+            </a:schemeClr>
+          </a:lnRef>
+          <a:fillRef idx="1">
+            <a:schemeClr val="accent1"/>
+          </a:fillRef>
+          <a:effectRef idx="0">
+            <a:schemeClr val="accent1"/>
+          </a:effectRef>
+          <a:fontRef idx="minor">
+            <a:schemeClr val="lt1"/>
+          </a:fontRef>
+        </p:style>
+        <p:txBody>
+          <a:bodyPr rtlCol="0" anchor="ctr"/>
+          <a:lstStyle/>
+          <a:p>
+            <a:pPr algn="ctr"/>
+            <a:r>
+              <a:rPr lang="en-AU" sz="1600" dirty="0">
+                <a:solidFill>
+                  <a:schemeClr val="tx1"/>
+                </a:solidFill>
+              </a:rPr>
+              <a:t>Application</a:t>
+            </a:r>
+            <a:endParaRPr lang="en-US" sz="1600" dirty="0">
+              <a:solidFill>
+                <a:schemeClr val="tx1"/>
+              </a:solidFill>
+            </a:endParaRPr>
+          </a:p>
+        </p:txBody>
+      </p:sp>
+      <p:sp>
+        <p:nvSpPr>
+          <p:cNvPr id="9" name="Rectangle: Rounded Corners 8">
+            <a:extLst>
+              <a:ext uri="{FF2B5EF4-FFF2-40B4-BE49-F238E27FC236}">
+                <a16:creationId xmlns:a16="http://schemas.microsoft.com/office/drawing/2014/main" id="{F8260DF7-87C4-62F8-DD93-C902D73FE3BC}"/>
+              </a:ext>
+            </a:extLst>
+          </p:cNvPr>
+          <p:cNvSpPr/>
+          <p:nvPr/>
+        </p:nvSpPr>
+        <p:spPr>
+          <a:xfrm>
+            <a:off x="5449754" y="1833058"/>
+            <a:ext cx="1801334" cy="392906"/>
+          </a:xfrm>
+          <a:prstGeom prst="roundRect">
+            <a:avLst/>
+          </a:prstGeom>
+          <a:solidFill>
+            <a:schemeClr val="accent1">
+              <a:alpha val="21000"/>
+            </a:schemeClr>
+          </a:solidFill>
+        </p:spPr>
+        <p:style>
+          <a:lnRef idx="2">
+            <a:schemeClr val="accent1">
+              <a:shade val="15000"/>
+            </a:schemeClr>
+          </a:lnRef>
+          <a:fillRef idx="1">
+            <a:schemeClr val="accent1"/>
+          </a:fillRef>
+          <a:effectRef idx="0">
+            <a:schemeClr val="accent1"/>
+          </a:effectRef>
+          <a:fontRef idx="minor">
+            <a:schemeClr val="lt1"/>
+          </a:fontRef>
+        </p:style>
+        <p:txBody>
+          <a:bodyPr rtlCol="0" anchor="ctr"/>
+          <a:lstStyle/>
+          <a:p>
+            <a:pPr algn="ctr"/>
+            <a:r>
+              <a:rPr lang="en-AU" sz="1600" dirty="0">
+                <a:solidFill>
+                  <a:schemeClr val="tx1"/>
+                </a:solidFill>
+              </a:rPr>
+              <a:t>Role</a:t>
+            </a:r>
+            <a:endParaRPr lang="en-US" sz="1600" dirty="0">
+              <a:solidFill>
+                <a:schemeClr val="tx1"/>
+              </a:solidFill>
+            </a:endParaRPr>
+          </a:p>
+        </p:txBody>
+      </p:sp>
+      <p:sp>
+        <p:nvSpPr>
+          <p:cNvPr id="11" name="Rectangle: Rounded Corners 10">
+            <a:extLst>
+              <a:ext uri="{FF2B5EF4-FFF2-40B4-BE49-F238E27FC236}">
+                <a16:creationId xmlns:a16="http://schemas.microsoft.com/office/drawing/2014/main" id="{24E973F8-F2A6-E754-4836-B8AF676D186E}"/>
+              </a:ext>
+            </a:extLst>
+          </p:cNvPr>
+          <p:cNvSpPr/>
+          <p:nvPr/>
+        </p:nvSpPr>
+        <p:spPr>
+          <a:xfrm>
+            <a:off x="2570434" y="1833058"/>
+            <a:ext cx="1801334" cy="392906"/>
+          </a:xfrm>
+          <a:prstGeom prst="roundRect">
+            <a:avLst/>
+          </a:prstGeom>
+          <a:solidFill>
+            <a:schemeClr val="accent1">
+              <a:alpha val="21000"/>
+            </a:schemeClr>
+          </a:solidFill>
+        </p:spPr>
+        <p:style>
+          <a:lnRef idx="2">
+            <a:schemeClr val="accent1">
+              <a:shade val="15000"/>
+            </a:schemeClr>
+          </a:lnRef>
+          <a:fillRef idx="1">
+            <a:schemeClr val="accent1"/>
+          </a:fillRef>
+          <a:effectRef idx="0">
+            <a:schemeClr val="accent1"/>
+          </a:effectRef>
+          <a:fontRef idx="minor">
+            <a:schemeClr val="lt1"/>
+          </a:fontRef>
+        </p:style>
+        <p:txBody>
+          <a:bodyPr rtlCol="0" anchor="ctr"/>
+          <a:lstStyle/>
+          <a:p>
+            <a:pPr algn="ctr"/>
+            <a:r>
+              <a:rPr lang="en-AU" sz="1600" dirty="0">
+                <a:solidFill>
+                  <a:schemeClr val="tx1"/>
+                </a:solidFill>
+              </a:rPr>
+              <a:t>User</a:t>
+            </a:r>
+            <a:endParaRPr lang="en-US" sz="1600" dirty="0">
+              <a:solidFill>
+                <a:schemeClr val="tx1"/>
+              </a:solidFill>
+            </a:endParaRPr>
+          </a:p>
+        </p:txBody>
+      </p:sp>
+      <p:sp>
+        <p:nvSpPr>
+          <p:cNvPr id="24" name="Rectangle: Rounded Corners 23">
+            <a:extLst>
+              <a:ext uri="{FF2B5EF4-FFF2-40B4-BE49-F238E27FC236}">
+                <a16:creationId xmlns:a16="http://schemas.microsoft.com/office/drawing/2014/main" id="{2199673F-629D-5CAF-93C6-E8854CCD81D2}"/>
+              </a:ext>
+            </a:extLst>
+          </p:cNvPr>
+          <p:cNvSpPr/>
+          <p:nvPr/>
+        </p:nvSpPr>
+        <p:spPr>
+          <a:xfrm>
+            <a:off x="5181900" y="388231"/>
+            <a:ext cx="2333296" cy="735726"/>
+          </a:xfrm>
+          <a:prstGeom prst="roundRect">
+            <a:avLst/>
+          </a:prstGeom>
+          <a:solidFill>
+            <a:schemeClr val="bg1">
+              <a:lumMod val="85000"/>
+              <a:alpha val="21000"/>
+            </a:schemeClr>
+          </a:solidFill>
+        </p:spPr>
+        <p:style>
+          <a:lnRef idx="2">
+            <a:schemeClr val="accent1">
+              <a:shade val="15000"/>
+            </a:schemeClr>
+          </a:lnRef>
+          <a:fillRef idx="1">
+            <a:schemeClr val="accent1"/>
+          </a:fillRef>
+          <a:effectRef idx="0">
+            <a:schemeClr val="accent1"/>
+          </a:effectRef>
+          <a:fontRef idx="minor">
+            <a:schemeClr val="lt1"/>
+          </a:fontRef>
+        </p:style>
+        <p:txBody>
+          <a:bodyPr rtlCol="0" anchor="ctr"/>
+          <a:lstStyle/>
+          <a:p>
+            <a:pPr algn="ctr"/>
+            <a:r>
+              <a:rPr lang="en-AU" sz="1600" dirty="0" err="1">
+                <a:solidFill>
+                  <a:schemeClr val="tx1"/>
+                </a:solidFill>
+              </a:rPr>
+              <a:t>BfsTenant</a:t>
+            </a:r>
+            <a:endParaRPr lang="en-US" sz="1600" dirty="0">
+              <a:solidFill>
+                <a:schemeClr val="tx1"/>
+              </a:solidFill>
+            </a:endParaRPr>
+          </a:p>
+        </p:txBody>
+      </p:sp>
+      <p:sp>
+        <p:nvSpPr>
+          <p:cNvPr id="26" name="Rectangle: Rounded Corners 25">
+            <a:extLst>
+              <a:ext uri="{FF2B5EF4-FFF2-40B4-BE49-F238E27FC236}">
+                <a16:creationId xmlns:a16="http://schemas.microsoft.com/office/drawing/2014/main" id="{F410340E-C040-3537-89DE-8B5C317E0055}"/>
+              </a:ext>
+            </a:extLst>
+          </p:cNvPr>
+          <p:cNvSpPr/>
+          <p:nvPr/>
+        </p:nvSpPr>
+        <p:spPr>
+          <a:xfrm>
+            <a:off x="2279495" y="388231"/>
+            <a:ext cx="2333296" cy="735726"/>
+          </a:xfrm>
+          <a:prstGeom prst="roundRect">
+            <a:avLst/>
+          </a:prstGeom>
+          <a:solidFill>
+            <a:schemeClr val="bg1">
+              <a:lumMod val="85000"/>
+              <a:alpha val="21000"/>
+            </a:schemeClr>
+          </a:solidFill>
+        </p:spPr>
+        <p:style>
+          <a:lnRef idx="2">
+            <a:schemeClr val="accent1">
+              <a:shade val="15000"/>
+            </a:schemeClr>
+          </a:lnRef>
+          <a:fillRef idx="1">
+            <a:schemeClr val="accent1"/>
+          </a:fillRef>
+          <a:effectRef idx="0">
+            <a:schemeClr val="accent1"/>
+          </a:effectRef>
+          <a:fontRef idx="minor">
+            <a:schemeClr val="lt1"/>
+          </a:fontRef>
+        </p:style>
+        <p:txBody>
+          <a:bodyPr rtlCol="0" anchor="ctr"/>
+          <a:lstStyle/>
+          <a:p>
+            <a:pPr algn="ctr"/>
+            <a:r>
+              <a:rPr lang="en-AU" sz="1600" dirty="0" err="1">
+                <a:solidFill>
+                  <a:schemeClr val="tx1"/>
+                </a:solidFill>
+              </a:rPr>
+              <a:t>AspNetUser</a:t>
+            </a:r>
+            <a:endParaRPr lang="en-US" sz="1600" dirty="0">
+              <a:solidFill>
+                <a:schemeClr val="tx1"/>
+              </a:solidFill>
+            </a:endParaRPr>
+          </a:p>
+        </p:txBody>
+      </p:sp>
+      <p:cxnSp>
+        <p:nvCxnSpPr>
+          <p:cNvPr id="28" name="Straight Arrow Connector 27">
+            <a:extLst>
+              <a:ext uri="{FF2B5EF4-FFF2-40B4-BE49-F238E27FC236}">
+                <a16:creationId xmlns:a16="http://schemas.microsoft.com/office/drawing/2014/main" id="{42B2A66F-60C1-BAF0-54E7-7A86C4DB40A6}"/>
+              </a:ext>
+            </a:extLst>
+          </p:cNvPr>
+          <p:cNvCxnSpPr>
+            <a:cxnSpLocks/>
+            <a:stCxn id="26" idx="2"/>
+            <a:endCxn id="11" idx="0"/>
+          </p:cNvCxnSpPr>
+          <p:nvPr/>
+        </p:nvCxnSpPr>
+        <p:spPr>
+          <a:xfrm>
+            <a:off x="3446143" y="1123957"/>
+            <a:ext cx="24958" cy="709101"/>
+          </a:xfrm>
+          <a:prstGeom prst="straightConnector1">
+            <a:avLst/>
+          </a:prstGeom>
+          <a:ln>
+            <a:tailEnd type="triangle"/>
+          </a:ln>
+        </p:spPr>
+        <p:style>
+          <a:lnRef idx="2">
+            <a:schemeClr val="accent1"/>
+          </a:lnRef>
+          <a:fillRef idx="0">
+            <a:schemeClr val="accent1"/>
+          </a:fillRef>
+          <a:effectRef idx="1">
+            <a:schemeClr val="accent1"/>
+          </a:effectRef>
+          <a:fontRef idx="minor">
+            <a:schemeClr val="tx1"/>
+          </a:fontRef>
+        </p:style>
+      </p:cxnSp>
+      <p:sp>
+        <p:nvSpPr>
+          <p:cNvPr id="41" name="Rectangle: Rounded Corners 40">
+            <a:extLst>
+              <a:ext uri="{FF2B5EF4-FFF2-40B4-BE49-F238E27FC236}">
+                <a16:creationId xmlns:a16="http://schemas.microsoft.com/office/drawing/2014/main" id="{80892785-EB90-D2EE-A1A2-AF2628C53879}"/>
+              </a:ext>
+            </a:extLst>
+          </p:cNvPr>
+          <p:cNvSpPr/>
+          <p:nvPr/>
+        </p:nvSpPr>
+        <p:spPr>
+          <a:xfrm>
+            <a:off x="8210884" y="2583692"/>
+            <a:ext cx="1801334" cy="392906"/>
+          </a:xfrm>
+          <a:prstGeom prst="roundRect">
+            <a:avLst/>
+          </a:prstGeom>
+          <a:solidFill>
+            <a:schemeClr val="accent2">
+              <a:alpha val="21000"/>
+            </a:schemeClr>
+          </a:solidFill>
+        </p:spPr>
+        <p:style>
+          <a:lnRef idx="2">
+            <a:schemeClr val="accent1">
+              <a:shade val="15000"/>
+            </a:schemeClr>
+          </a:lnRef>
+          <a:fillRef idx="1">
+            <a:schemeClr val="accent1"/>
+          </a:fillRef>
+          <a:effectRef idx="0">
+            <a:schemeClr val="accent1"/>
+          </a:effectRef>
+          <a:fontRef idx="minor">
+            <a:schemeClr val="lt1"/>
+          </a:fontRef>
+        </p:style>
+        <p:txBody>
+          <a:bodyPr rtlCol="0" anchor="ctr"/>
+          <a:lstStyle/>
+          <a:p>
+            <a:pPr algn="ctr"/>
+            <a:r>
+              <a:rPr lang="en-AU" sz="1600" dirty="0">
+                <a:solidFill>
+                  <a:schemeClr val="tx1"/>
+                </a:solidFill>
+              </a:rPr>
+              <a:t>Investor</a:t>
+            </a:r>
+            <a:endParaRPr lang="en-US" sz="1600" dirty="0">
+              <a:solidFill>
+                <a:schemeClr val="tx1"/>
+              </a:solidFill>
+            </a:endParaRPr>
+          </a:p>
+        </p:txBody>
+      </p:sp>
+      <p:sp>
+        <p:nvSpPr>
+          <p:cNvPr id="43" name="Rectangle: Rounded Corners 42">
+            <a:extLst>
+              <a:ext uri="{FF2B5EF4-FFF2-40B4-BE49-F238E27FC236}">
+                <a16:creationId xmlns:a16="http://schemas.microsoft.com/office/drawing/2014/main" id="{EA2B2F91-742F-0386-4935-6AFD88BBBFA6}"/>
+              </a:ext>
+            </a:extLst>
+          </p:cNvPr>
+          <p:cNvSpPr/>
+          <p:nvPr/>
+        </p:nvSpPr>
+        <p:spPr>
+          <a:xfrm>
+            <a:off x="5449754" y="2583692"/>
+            <a:ext cx="1801334" cy="392906"/>
+          </a:xfrm>
+          <a:prstGeom prst="roundRect">
+            <a:avLst/>
+          </a:prstGeom>
+          <a:solidFill>
+            <a:schemeClr val="accent2">
+              <a:alpha val="21000"/>
+            </a:schemeClr>
+          </a:solidFill>
+        </p:spPr>
+        <p:style>
+          <a:lnRef idx="2">
+            <a:schemeClr val="accent1">
+              <a:shade val="15000"/>
+            </a:schemeClr>
+          </a:lnRef>
+          <a:fillRef idx="1">
+            <a:schemeClr val="accent1"/>
+          </a:fillRef>
+          <a:effectRef idx="0">
+            <a:schemeClr val="accent1"/>
+          </a:effectRef>
+          <a:fontRef idx="minor">
+            <a:schemeClr val="lt1"/>
+          </a:fontRef>
+        </p:style>
+        <p:txBody>
+          <a:bodyPr rtlCol="0" anchor="ctr"/>
+          <a:lstStyle/>
+          <a:p>
+            <a:pPr algn="ctr"/>
+            <a:r>
+              <a:rPr lang="en-AU" sz="1600" dirty="0">
+                <a:solidFill>
+                  <a:schemeClr val="tx1"/>
+                </a:solidFill>
+              </a:rPr>
+              <a:t>Broker</a:t>
+            </a:r>
+            <a:endParaRPr lang="en-US" sz="1600" dirty="0">
+              <a:solidFill>
+                <a:schemeClr val="tx1"/>
+              </a:solidFill>
+            </a:endParaRPr>
+          </a:p>
+        </p:txBody>
+      </p:sp>
+      <p:sp>
+        <p:nvSpPr>
+          <p:cNvPr id="45" name="Rectangle: Rounded Corners 44">
+            <a:extLst>
+              <a:ext uri="{FF2B5EF4-FFF2-40B4-BE49-F238E27FC236}">
+                <a16:creationId xmlns:a16="http://schemas.microsoft.com/office/drawing/2014/main" id="{A433504C-268F-B8E1-9745-46D47F062BA1}"/>
+              </a:ext>
+            </a:extLst>
+          </p:cNvPr>
+          <p:cNvSpPr/>
+          <p:nvPr/>
+        </p:nvSpPr>
+        <p:spPr>
+          <a:xfrm>
+            <a:off x="2570434" y="2583692"/>
+            <a:ext cx="1801334" cy="392906"/>
+          </a:xfrm>
+          <a:prstGeom prst="roundRect">
+            <a:avLst/>
+          </a:prstGeom>
+          <a:solidFill>
+            <a:schemeClr val="accent2">
+              <a:alpha val="21000"/>
+            </a:schemeClr>
+          </a:solidFill>
+        </p:spPr>
+        <p:style>
+          <a:lnRef idx="2">
+            <a:schemeClr val="accent1">
+              <a:shade val="15000"/>
+            </a:schemeClr>
+          </a:lnRef>
+          <a:fillRef idx="1">
+            <a:schemeClr val="accent1"/>
+          </a:fillRef>
+          <a:effectRef idx="0">
+            <a:schemeClr val="accent1"/>
+          </a:effectRef>
+          <a:fontRef idx="minor">
+            <a:schemeClr val="lt1"/>
+          </a:fontRef>
+        </p:style>
+        <p:txBody>
+          <a:bodyPr rtlCol="0" anchor="ctr"/>
+          <a:lstStyle/>
+          <a:p>
+            <a:pPr algn="ctr"/>
+            <a:r>
+              <a:rPr lang="en-AU" sz="1600" dirty="0" err="1">
+                <a:solidFill>
+                  <a:schemeClr val="tx1"/>
+                </a:solidFill>
+              </a:rPr>
+              <a:t>TradingRoom</a:t>
+            </a:r>
+            <a:endParaRPr lang="en-US" sz="1600" dirty="0">
+              <a:solidFill>
+                <a:schemeClr val="tx1"/>
+              </a:solidFill>
+            </a:endParaRPr>
+          </a:p>
+        </p:txBody>
+      </p:sp>
+      <p:sp>
+        <p:nvSpPr>
+          <p:cNvPr id="47" name="Rectangle: Rounded Corners 46">
+            <a:extLst>
+              <a:ext uri="{FF2B5EF4-FFF2-40B4-BE49-F238E27FC236}">
+                <a16:creationId xmlns:a16="http://schemas.microsoft.com/office/drawing/2014/main" id="{DECB229A-5988-5AB3-BD89-C40E3C4E1E00}"/>
+              </a:ext>
+            </a:extLst>
+          </p:cNvPr>
+          <p:cNvSpPr/>
+          <p:nvPr/>
+        </p:nvSpPr>
+        <p:spPr>
+          <a:xfrm>
+            <a:off x="8210884" y="3334326"/>
+            <a:ext cx="1801334" cy="392906"/>
+          </a:xfrm>
+          <a:prstGeom prst="roundRect">
+            <a:avLst/>
+          </a:prstGeom>
+          <a:solidFill>
+            <a:srgbClr val="FF0000">
+              <a:alpha val="21000"/>
+            </a:srgbClr>
+          </a:solidFill>
+        </p:spPr>
+        <p:style>
+          <a:lnRef idx="2">
+            <a:schemeClr val="accent1">
+              <a:shade val="15000"/>
+            </a:schemeClr>
+          </a:lnRef>
+          <a:fillRef idx="1">
+            <a:schemeClr val="accent1"/>
+          </a:fillRef>
+          <a:effectRef idx="0">
+            <a:schemeClr val="accent1"/>
+          </a:effectRef>
+          <a:fontRef idx="minor">
+            <a:schemeClr val="lt1"/>
+          </a:fontRef>
+        </p:style>
+        <p:txBody>
+          <a:bodyPr rtlCol="0" anchor="ctr"/>
+          <a:lstStyle/>
+          <a:p>
+            <a:pPr algn="ctr"/>
+            <a:r>
+              <a:rPr lang="en-AU" sz="1600" dirty="0" err="1">
+                <a:solidFill>
+                  <a:schemeClr val="tx1"/>
+                </a:solidFill>
+              </a:rPr>
+              <a:t>MonthlyItem</a:t>
+            </a:r>
+            <a:endParaRPr lang="en-US" sz="1600" dirty="0">
+              <a:solidFill>
+                <a:schemeClr val="tx1"/>
+              </a:solidFill>
+            </a:endParaRPr>
+          </a:p>
+        </p:txBody>
+      </p:sp>
+      <p:sp>
+        <p:nvSpPr>
+          <p:cNvPr id="49" name="Rectangle: Rounded Corners 48">
+            <a:extLst>
+              <a:ext uri="{FF2B5EF4-FFF2-40B4-BE49-F238E27FC236}">
+                <a16:creationId xmlns:a16="http://schemas.microsoft.com/office/drawing/2014/main" id="{7173D389-5470-FEB4-A7DA-5DD0365B556B}"/>
+              </a:ext>
+            </a:extLst>
+          </p:cNvPr>
+          <p:cNvSpPr/>
+          <p:nvPr/>
+        </p:nvSpPr>
+        <p:spPr>
+          <a:xfrm>
+            <a:off x="5449754" y="3334326"/>
+            <a:ext cx="1801334" cy="392906"/>
+          </a:xfrm>
+          <a:prstGeom prst="roundRect">
+            <a:avLst/>
+          </a:prstGeom>
+          <a:solidFill>
+            <a:srgbClr val="FF0000">
+              <a:alpha val="21000"/>
+            </a:srgbClr>
+          </a:solidFill>
+        </p:spPr>
+        <p:style>
+          <a:lnRef idx="2">
+            <a:schemeClr val="accent1">
+              <a:shade val="15000"/>
+            </a:schemeClr>
+          </a:lnRef>
+          <a:fillRef idx="1">
+            <a:schemeClr val="accent1"/>
+          </a:fillRef>
+          <a:effectRef idx="0">
+            <a:schemeClr val="accent1"/>
+          </a:effectRef>
+          <a:fontRef idx="minor">
+            <a:schemeClr val="lt1"/>
+          </a:fontRef>
+        </p:style>
+        <p:txBody>
+          <a:bodyPr rtlCol="0" anchor="ctr"/>
+          <a:lstStyle/>
+          <a:p>
+            <a:pPr algn="ctr"/>
+            <a:r>
+              <a:rPr lang="en-AU" sz="1600" dirty="0" err="1">
+                <a:solidFill>
+                  <a:schemeClr val="tx1"/>
+                </a:solidFill>
+              </a:rPr>
+              <a:t>SalaryItem</a:t>
+            </a:r>
+            <a:endParaRPr lang="en-US" sz="1600" dirty="0">
+              <a:solidFill>
+                <a:schemeClr val="tx1"/>
+              </a:solidFill>
+            </a:endParaRPr>
+          </a:p>
+        </p:txBody>
+      </p:sp>
+      <p:sp>
+        <p:nvSpPr>
+          <p:cNvPr id="51" name="Rectangle: Rounded Corners 50">
+            <a:extLst>
+              <a:ext uri="{FF2B5EF4-FFF2-40B4-BE49-F238E27FC236}">
+                <a16:creationId xmlns:a16="http://schemas.microsoft.com/office/drawing/2014/main" id="{DA1C6CAD-7557-E477-9FB2-780D252A439F}"/>
+              </a:ext>
+            </a:extLst>
+          </p:cNvPr>
+          <p:cNvSpPr/>
+          <p:nvPr/>
+        </p:nvSpPr>
+        <p:spPr>
+          <a:xfrm>
+            <a:off x="2570434" y="3334326"/>
+            <a:ext cx="1801334" cy="392906"/>
+          </a:xfrm>
+          <a:prstGeom prst="roundRect">
+            <a:avLst/>
+          </a:prstGeom>
+          <a:solidFill>
+            <a:srgbClr val="FF0000">
+              <a:alpha val="21000"/>
+            </a:srgbClr>
+          </a:solidFill>
+        </p:spPr>
+        <p:style>
+          <a:lnRef idx="2">
+            <a:schemeClr val="accent1">
+              <a:shade val="15000"/>
+            </a:schemeClr>
+          </a:lnRef>
+          <a:fillRef idx="1">
+            <a:schemeClr val="accent1"/>
+          </a:fillRef>
+          <a:effectRef idx="0">
+            <a:schemeClr val="accent1"/>
+          </a:effectRef>
+          <a:fontRef idx="minor">
+            <a:schemeClr val="lt1"/>
+          </a:fontRef>
+        </p:style>
+        <p:txBody>
+          <a:bodyPr rtlCol="0" anchor="ctr"/>
+          <a:lstStyle/>
+          <a:p>
+            <a:pPr algn="ctr"/>
+            <a:r>
+              <a:rPr lang="en-AU" sz="1600" dirty="0">
+                <a:solidFill>
+                  <a:schemeClr val="tx1"/>
+                </a:solidFill>
+              </a:rPr>
+              <a:t>Employee</a:t>
+            </a:r>
+            <a:endParaRPr lang="en-US" sz="1600" dirty="0">
+              <a:solidFill>
+                <a:schemeClr val="tx1"/>
+              </a:solidFill>
+            </a:endParaRPr>
+          </a:p>
+        </p:txBody>
+      </p:sp>
+      <p:sp>
+        <p:nvSpPr>
+          <p:cNvPr id="52" name="Scroll: Vertical 51">
+            <a:extLst>
+              <a:ext uri="{FF2B5EF4-FFF2-40B4-BE49-F238E27FC236}">
+                <a16:creationId xmlns:a16="http://schemas.microsoft.com/office/drawing/2014/main" id="{F6C59AFF-B60A-EC42-4110-AF09023C18A6}"/>
+              </a:ext>
+            </a:extLst>
+          </p:cNvPr>
+          <p:cNvSpPr/>
+          <p:nvPr/>
+        </p:nvSpPr>
+        <p:spPr>
+          <a:xfrm>
+            <a:off x="1736436" y="1833058"/>
+            <a:ext cx="443346" cy="392906"/>
+          </a:xfrm>
+          <a:prstGeom prst="verticalScroll">
+            <a:avLst/>
+          </a:prstGeom>
+        </p:spPr>
+        <p:style>
+          <a:lnRef idx="2">
+            <a:schemeClr val="accent1">
+              <a:shade val="15000"/>
+            </a:schemeClr>
+          </a:lnRef>
+          <a:fillRef idx="1">
+            <a:schemeClr val="accent1"/>
+          </a:fillRef>
+          <a:effectRef idx="0">
+            <a:schemeClr val="accent1"/>
+          </a:effectRef>
+          <a:fontRef idx="minor">
+            <a:schemeClr val="lt1"/>
+          </a:fontRef>
+        </p:style>
+        <p:txBody>
+          <a:bodyPr rtlCol="0" anchor="ctr"/>
+          <a:lstStyle/>
+          <a:p>
+            <a:pPr algn="ctr"/>
+            <a:endParaRPr lang="en-US"/>
+          </a:p>
+        </p:txBody>
+      </p:sp>
+      <p:sp>
+        <p:nvSpPr>
+          <p:cNvPr id="54" name="Scroll: Vertical 53">
+            <a:extLst>
+              <a:ext uri="{FF2B5EF4-FFF2-40B4-BE49-F238E27FC236}">
+                <a16:creationId xmlns:a16="http://schemas.microsoft.com/office/drawing/2014/main" id="{E6A38B9F-D8A5-7A81-ACE1-58AAD136423B}"/>
+              </a:ext>
+            </a:extLst>
+          </p:cNvPr>
+          <p:cNvSpPr/>
+          <p:nvPr/>
+        </p:nvSpPr>
+        <p:spPr>
+          <a:xfrm>
+            <a:off x="1789967" y="2542825"/>
+            <a:ext cx="443346" cy="392906"/>
+          </a:xfrm>
+          <a:prstGeom prst="verticalScroll">
+            <a:avLst/>
+          </a:prstGeom>
+        </p:spPr>
+        <p:style>
+          <a:lnRef idx="2">
+            <a:schemeClr val="accent1">
+              <a:shade val="15000"/>
+            </a:schemeClr>
+          </a:lnRef>
+          <a:fillRef idx="1">
+            <a:schemeClr val="accent1"/>
+          </a:fillRef>
+          <a:effectRef idx="0">
+            <a:schemeClr val="accent1"/>
+          </a:effectRef>
+          <a:fontRef idx="minor">
+            <a:schemeClr val="lt1"/>
+          </a:fontRef>
+        </p:style>
+        <p:txBody>
+          <a:bodyPr rtlCol="0" anchor="ctr"/>
+          <a:lstStyle/>
+          <a:p>
+            <a:pPr algn="ctr"/>
+            <a:endParaRPr lang="en-US"/>
+          </a:p>
+        </p:txBody>
+      </p:sp>
+      <p:sp>
+        <p:nvSpPr>
+          <p:cNvPr id="56" name="Scroll: Vertical 55">
+            <a:extLst>
+              <a:ext uri="{FF2B5EF4-FFF2-40B4-BE49-F238E27FC236}">
+                <a16:creationId xmlns:a16="http://schemas.microsoft.com/office/drawing/2014/main" id="{A3B48AED-67C8-DEFB-1743-FEDCB0885FE7}"/>
+              </a:ext>
+            </a:extLst>
+          </p:cNvPr>
+          <p:cNvSpPr/>
+          <p:nvPr/>
+        </p:nvSpPr>
+        <p:spPr>
+          <a:xfrm>
+            <a:off x="1789967" y="3334326"/>
+            <a:ext cx="443346" cy="392906"/>
+          </a:xfrm>
+          <a:prstGeom prst="verticalScroll">
+            <a:avLst/>
+          </a:prstGeom>
+        </p:spPr>
+        <p:style>
+          <a:lnRef idx="2">
+            <a:schemeClr val="accent1">
+              <a:shade val="15000"/>
+            </a:schemeClr>
+          </a:lnRef>
+          <a:fillRef idx="1">
+            <a:schemeClr val="accent1"/>
+          </a:fillRef>
+          <a:effectRef idx="0">
+            <a:schemeClr val="accent1"/>
+          </a:effectRef>
+          <a:fontRef idx="minor">
+            <a:schemeClr val="lt1"/>
+          </a:fontRef>
+        </p:style>
+        <p:txBody>
+          <a:bodyPr rtlCol="0" anchor="ctr"/>
+          <a:lstStyle/>
+          <a:p>
+            <a:pPr algn="ctr"/>
+            <a:endParaRPr lang="en-US"/>
+          </a:p>
+        </p:txBody>
+      </p:sp>
+      <p:sp>
+        <p:nvSpPr>
+          <p:cNvPr id="58" name="Scroll: Vertical 57">
+            <a:extLst>
+              <a:ext uri="{FF2B5EF4-FFF2-40B4-BE49-F238E27FC236}">
+                <a16:creationId xmlns:a16="http://schemas.microsoft.com/office/drawing/2014/main" id="{640DC75B-08C6-212C-1AAE-126C11DB511C}"/>
+              </a:ext>
+            </a:extLst>
+          </p:cNvPr>
+          <p:cNvSpPr/>
+          <p:nvPr/>
+        </p:nvSpPr>
+        <p:spPr>
+          <a:xfrm>
+            <a:off x="90475" y="4513354"/>
+            <a:ext cx="2978965" cy="2210719"/>
+          </a:xfrm>
+          <a:prstGeom prst="verticalScroll">
+            <a:avLst/>
+          </a:prstGeom>
+        </p:spPr>
+        <p:style>
+          <a:lnRef idx="2">
+            <a:schemeClr val="accent1">
+              <a:shade val="15000"/>
+            </a:schemeClr>
+          </a:lnRef>
+          <a:fillRef idx="1">
+            <a:schemeClr val="accent1"/>
+          </a:fillRef>
+          <a:effectRef idx="0">
+            <a:schemeClr val="accent1"/>
+          </a:effectRef>
+          <a:fontRef idx="minor">
+            <a:schemeClr val="lt1"/>
+          </a:fontRef>
+        </p:style>
+        <p:txBody>
+          <a:bodyPr rtlCol="0" anchor="ctr"/>
+          <a:lstStyle/>
+          <a:p>
+            <a:pPr algn="ctr"/>
+            <a:r>
+              <a:rPr lang="en-AU" dirty="0" err="1"/>
+              <a:t>MenuItem</a:t>
+            </a:r>
+            <a:endParaRPr lang="en-US" dirty="0"/>
+          </a:p>
+        </p:txBody>
+      </p:sp>
+      <p:sp>
+        <p:nvSpPr>
+          <p:cNvPr id="60" name="Rectangle: Rounded Corners 59">
+            <a:extLst>
+              <a:ext uri="{FF2B5EF4-FFF2-40B4-BE49-F238E27FC236}">
+                <a16:creationId xmlns:a16="http://schemas.microsoft.com/office/drawing/2014/main" id="{1F04ECC2-2618-4660-9F5B-A1B884E4CD4F}"/>
+              </a:ext>
+            </a:extLst>
+          </p:cNvPr>
+          <p:cNvSpPr/>
+          <p:nvPr/>
+        </p:nvSpPr>
+        <p:spPr>
+          <a:xfrm>
+            <a:off x="4081578" y="5537590"/>
+            <a:ext cx="1220394" cy="392906"/>
+          </a:xfrm>
+          <a:prstGeom prst="roundRect">
+            <a:avLst/>
+          </a:prstGeom>
+          <a:solidFill>
+            <a:schemeClr val="accent1">
+              <a:alpha val="21000"/>
+            </a:schemeClr>
+          </a:solidFill>
+        </p:spPr>
+        <p:style>
+          <a:lnRef idx="2">
+            <a:schemeClr val="accent1">
+              <a:shade val="15000"/>
+            </a:schemeClr>
+          </a:lnRef>
+          <a:fillRef idx="1">
+            <a:schemeClr val="accent1"/>
+          </a:fillRef>
+          <a:effectRef idx="0">
+            <a:schemeClr val="accent1"/>
+          </a:effectRef>
+          <a:fontRef idx="minor">
+            <a:schemeClr val="lt1"/>
+          </a:fontRef>
+        </p:style>
+        <p:txBody>
+          <a:bodyPr rtlCol="0" anchor="ctr"/>
+          <a:lstStyle/>
+          <a:p>
+            <a:pPr algn="ctr"/>
+            <a:r>
+              <a:rPr lang="en-AU" sz="1400" dirty="0">
+                <a:solidFill>
+                  <a:schemeClr val="tx1"/>
+                </a:solidFill>
+              </a:rPr>
+              <a:t>Application</a:t>
+            </a:r>
+            <a:endParaRPr lang="en-US" sz="1400" dirty="0">
+              <a:solidFill>
+                <a:schemeClr val="tx1"/>
+              </a:solidFill>
+            </a:endParaRPr>
+          </a:p>
+        </p:txBody>
+      </p:sp>
+      <p:sp>
+        <p:nvSpPr>
+          <p:cNvPr id="62" name="Rectangle: Rounded Corners 61">
+            <a:extLst>
+              <a:ext uri="{FF2B5EF4-FFF2-40B4-BE49-F238E27FC236}">
+                <a16:creationId xmlns:a16="http://schemas.microsoft.com/office/drawing/2014/main" id="{541E2CE8-0378-5B6E-D4E0-9F176614F40E}"/>
+              </a:ext>
+            </a:extLst>
+          </p:cNvPr>
+          <p:cNvSpPr/>
+          <p:nvPr/>
+        </p:nvSpPr>
+        <p:spPr>
+          <a:xfrm>
+            <a:off x="2823268" y="5537590"/>
+            <a:ext cx="1220394" cy="392906"/>
+          </a:xfrm>
+          <a:prstGeom prst="roundRect">
+            <a:avLst/>
+          </a:prstGeom>
+          <a:solidFill>
+            <a:schemeClr val="accent1">
+              <a:alpha val="21000"/>
+            </a:schemeClr>
+          </a:solidFill>
+        </p:spPr>
+        <p:style>
+          <a:lnRef idx="2">
+            <a:schemeClr val="accent1">
+              <a:shade val="15000"/>
+            </a:schemeClr>
+          </a:lnRef>
+          <a:fillRef idx="1">
+            <a:schemeClr val="accent1"/>
+          </a:fillRef>
+          <a:effectRef idx="0">
+            <a:schemeClr val="accent1"/>
+          </a:effectRef>
+          <a:fontRef idx="minor">
+            <a:schemeClr val="lt1"/>
+          </a:fontRef>
+        </p:style>
+        <p:txBody>
+          <a:bodyPr rtlCol="0" anchor="ctr"/>
+          <a:lstStyle/>
+          <a:p>
+            <a:pPr algn="ctr"/>
+            <a:r>
+              <a:rPr lang="en-AU" sz="1400" dirty="0">
+                <a:solidFill>
+                  <a:schemeClr val="tx1"/>
+                </a:solidFill>
+              </a:rPr>
+              <a:t>Role</a:t>
+            </a:r>
+            <a:endParaRPr lang="en-US" sz="1400" dirty="0">
+              <a:solidFill>
+                <a:schemeClr val="tx1"/>
+              </a:solidFill>
+            </a:endParaRPr>
+          </a:p>
+        </p:txBody>
+      </p:sp>
+      <p:pic>
+        <p:nvPicPr>
+          <p:cNvPr id="64" name="Graphic 63" descr="Programmer male outline">
+            <a:extLst>
+              <a:ext uri="{FF2B5EF4-FFF2-40B4-BE49-F238E27FC236}">
+                <a16:creationId xmlns:a16="http://schemas.microsoft.com/office/drawing/2014/main" id="{CC7F26EA-1F0D-F9E2-3B28-3240CBC0AA59}"/>
+              </a:ext>
+            </a:extLst>
+          </p:cNvPr>
+          <p:cNvPicPr>
+            <a:picLocks noChangeAspect="1"/>
+          </p:cNvPicPr>
+          <p:nvPr/>
+        </p:nvPicPr>
+        <p:blipFill>
+          <a:blip>
+            <a:extLst>
+              <a:ext uri="{96DAC541-7B7A-43D3-8B79-37D633B846F1}">
+                <asvg:svgBlip xmlns:asvg="http://schemas.microsoft.com/office/drawing/2016/SVG/main" r:embed="rId2"/>
+              </a:ext>
+            </a:extLst>
+          </a:blip>
+          <a:stretch>
+            <a:fillRect/>
+          </a:stretch>
+        </p:blipFill>
+        <p:spPr>
+          <a:xfrm>
+            <a:off x="9276110" y="4293158"/>
+            <a:ext cx="2255545" cy="2255545"/>
+          </a:xfrm>
+          <a:prstGeom prst="rect">
+            <a:avLst/>
+          </a:prstGeom>
+          <a:effectLst>
+            <a:outerShdw blurRad="50800" dist="127000" dir="2700000" algn="tl" rotWithShape="0">
+              <a:schemeClr val="accent1">
+                <a:alpha val="40000"/>
+              </a:schemeClr>
+            </a:outerShdw>
+          </a:effectLst>
+        </p:spPr>
+      </p:pic>
+      <p:sp>
+        <p:nvSpPr>
+          <p:cNvPr id="66" name="Rectangle: Rounded Corners 65">
+            <a:extLst>
+              <a:ext uri="{FF2B5EF4-FFF2-40B4-BE49-F238E27FC236}">
+                <a16:creationId xmlns:a16="http://schemas.microsoft.com/office/drawing/2014/main" id="{6BB1E8C6-ACD2-D8C8-000F-C8EF8B1241FC}"/>
+              </a:ext>
+            </a:extLst>
+          </p:cNvPr>
+          <p:cNvSpPr/>
+          <p:nvPr/>
+        </p:nvSpPr>
+        <p:spPr>
+          <a:xfrm>
+            <a:off x="8481989" y="5537590"/>
+            <a:ext cx="1220394" cy="392906"/>
+          </a:xfrm>
+          <a:prstGeom prst="roundRect">
+            <a:avLst/>
+          </a:prstGeom>
+          <a:solidFill>
+            <a:schemeClr val="accent1">
+              <a:alpha val="21000"/>
+            </a:schemeClr>
+          </a:solidFill>
+        </p:spPr>
+        <p:style>
+          <a:lnRef idx="2">
+            <a:schemeClr val="accent1">
+              <a:shade val="15000"/>
+            </a:schemeClr>
+          </a:lnRef>
+          <a:fillRef idx="1">
+            <a:schemeClr val="accent1"/>
+          </a:fillRef>
+          <a:effectRef idx="0">
+            <a:schemeClr val="accent1"/>
+          </a:effectRef>
+          <a:fontRef idx="minor">
+            <a:schemeClr val="lt1"/>
+          </a:fontRef>
+        </p:style>
+        <p:txBody>
+          <a:bodyPr rtlCol="0" anchor="ctr"/>
+          <a:lstStyle/>
+          <a:p>
+            <a:pPr algn="ctr"/>
+            <a:r>
+              <a:rPr lang="en-AU" sz="1400" dirty="0">
+                <a:solidFill>
+                  <a:schemeClr val="tx1"/>
+                </a:solidFill>
+              </a:rPr>
+              <a:t>Application</a:t>
+            </a:r>
+            <a:endParaRPr lang="en-US" sz="1400" dirty="0">
+              <a:solidFill>
+                <a:schemeClr val="tx1"/>
+              </a:solidFill>
+            </a:endParaRPr>
+          </a:p>
+        </p:txBody>
+      </p:sp>
+      <p:sp>
+        <p:nvSpPr>
+          <p:cNvPr id="68" name="Rectangle: Rounded Corners 67">
+            <a:extLst>
+              <a:ext uri="{FF2B5EF4-FFF2-40B4-BE49-F238E27FC236}">
+                <a16:creationId xmlns:a16="http://schemas.microsoft.com/office/drawing/2014/main" id="{8DA47CAB-1028-4D11-BDCA-3953B50F9B18}"/>
+              </a:ext>
+            </a:extLst>
+          </p:cNvPr>
+          <p:cNvSpPr/>
+          <p:nvPr/>
+        </p:nvSpPr>
+        <p:spPr>
+          <a:xfrm>
+            <a:off x="7223679" y="5537590"/>
+            <a:ext cx="1220394" cy="392906"/>
+          </a:xfrm>
+          <a:prstGeom prst="roundRect">
+            <a:avLst/>
+          </a:prstGeom>
+          <a:solidFill>
+            <a:schemeClr val="accent1">
+              <a:alpha val="21000"/>
+            </a:schemeClr>
+          </a:solidFill>
+        </p:spPr>
+        <p:style>
+          <a:lnRef idx="2">
+            <a:schemeClr val="accent1">
+              <a:shade val="15000"/>
+            </a:schemeClr>
+          </a:lnRef>
+          <a:fillRef idx="1">
+            <a:schemeClr val="accent1"/>
+          </a:fillRef>
+          <a:effectRef idx="0">
+            <a:schemeClr val="accent1"/>
+          </a:effectRef>
+          <a:fontRef idx="minor">
+            <a:schemeClr val="lt1"/>
+          </a:fontRef>
+        </p:style>
+        <p:txBody>
+          <a:bodyPr rtlCol="0" anchor="ctr"/>
+          <a:lstStyle/>
+          <a:p>
+            <a:pPr algn="ctr"/>
+            <a:r>
+              <a:rPr lang="en-AU" sz="1400" dirty="0">
+                <a:solidFill>
+                  <a:schemeClr val="tx1"/>
+                </a:solidFill>
+              </a:rPr>
+              <a:t>Role</a:t>
+            </a:r>
+            <a:endParaRPr lang="en-US" sz="1400" dirty="0">
+              <a:solidFill>
+                <a:schemeClr val="tx1"/>
+              </a:solidFill>
+            </a:endParaRPr>
+          </a:p>
+        </p:txBody>
+      </p:sp>
+    </p:spTree>
+    <p:extLst>
+      <p:ext uri="{BB962C8B-B14F-4D97-AF65-F5344CB8AC3E}">
+        <p14:creationId xmlns:p14="http://schemas.microsoft.com/office/powerpoint/2010/main" val="4033068262"/>
+      </p:ext>
+    </p:extLst>
+  </p:cSld>
+  <p:clrMapOvr>
+    <a:masterClrMapping/>
+  </p:clrMapOvr>
+</p:sld>
+</file>
+
+<file path=ppt/slides/slide20.xml><?xml version="1.0" encoding="utf-8"?>
 <p:sld xmlns:a="http://schemas.openxmlformats.org/drawingml/2006/main" xmlns:r="http://schemas.openxmlformats.org/officeDocument/2006/relationships" xmlns:p="http://schemas.openxmlformats.org/presentationml/2006/main">
   <p:cSld>
     <p:spTree>
@@ -7517,1439 +9238,7 @@
 </p:sld>
 </file>
 
-<file path=ppt/slides/slide2.xml><?xml version="1.0" encoding="utf-8"?>
-<p:sld xmlns:a="http://schemas.openxmlformats.org/drawingml/2006/main" xmlns:r="http://schemas.openxmlformats.org/officeDocument/2006/relationships" xmlns:p="http://schemas.openxmlformats.org/presentationml/2006/main">
-  <p:cSld>
-    <p:spTree>
-      <p:nvGrpSpPr>
-        <p:cNvPr id="1" name=""/>
-        <p:cNvGrpSpPr/>
-        <p:nvPr/>
-      </p:nvGrpSpPr>
-      <p:grpSpPr>
-        <a:xfrm>
-          <a:off x="0" y="0"/>
-          <a:ext cx="0" cy="0"/>
-          <a:chOff x="0" y="0"/>
-          <a:chExt cx="0" cy="0"/>
-        </a:xfrm>
-      </p:grpSpPr>
-      <p:sp>
-        <p:nvSpPr>
-          <p:cNvPr id="14" name="Rectangle 13">
-            <a:extLst>
-              <a:ext uri="{FF2B5EF4-FFF2-40B4-BE49-F238E27FC236}">
-                <a16:creationId xmlns:a16="http://schemas.microsoft.com/office/drawing/2014/main" id="{8DD21041-9BF6-0D90-0159-1E9C2CC5D860}"/>
-              </a:ext>
-            </a:extLst>
-          </p:cNvPr>
-          <p:cNvSpPr/>
-          <p:nvPr/>
-        </p:nvSpPr>
-        <p:spPr>
-          <a:xfrm>
-            <a:off x="271387" y="263345"/>
-            <a:ext cx="10461812" cy="985498"/>
-          </a:xfrm>
-          <a:prstGeom prst="rect">
-            <a:avLst/>
-          </a:prstGeom>
-          <a:solidFill>
-            <a:schemeClr val="bg1">
-              <a:lumMod val="85000"/>
-              <a:alpha val="47000"/>
-            </a:schemeClr>
-          </a:solidFill>
-        </p:spPr>
-        <p:style>
-          <a:lnRef idx="2">
-            <a:schemeClr val="accent1">
-              <a:shade val="15000"/>
-            </a:schemeClr>
-          </a:lnRef>
-          <a:fillRef idx="1">
-            <a:schemeClr val="accent1"/>
-          </a:fillRef>
-          <a:effectRef idx="0">
-            <a:schemeClr val="accent1"/>
-          </a:effectRef>
-          <a:fontRef idx="minor">
-            <a:schemeClr val="lt1"/>
-          </a:fontRef>
-        </p:style>
-        <p:txBody>
-          <a:bodyPr rtlCol="0" anchor="ctr"/>
-          <a:lstStyle/>
-          <a:p>
-            <a:r>
-              <a:rPr lang="en-AU" dirty="0" err="1">
-                <a:solidFill>
-                  <a:schemeClr val="tx2"/>
-                </a:solidFill>
-              </a:rPr>
-              <a:t>BestFit</a:t>
-            </a:r>
-            <a:endParaRPr lang="en-US" dirty="0">
-              <a:solidFill>
-                <a:schemeClr val="tx2"/>
-              </a:solidFill>
-            </a:endParaRPr>
-          </a:p>
-        </p:txBody>
-      </p:sp>
-      <p:sp>
-        <p:nvSpPr>
-          <p:cNvPr id="12" name="Rectangle 11">
-            <a:extLst>
-              <a:ext uri="{FF2B5EF4-FFF2-40B4-BE49-F238E27FC236}">
-                <a16:creationId xmlns:a16="http://schemas.microsoft.com/office/drawing/2014/main" id="{8030EC64-EF9A-BF48-4413-6599A8DCD81B}"/>
-              </a:ext>
-            </a:extLst>
-          </p:cNvPr>
-          <p:cNvSpPr/>
-          <p:nvPr/>
-        </p:nvSpPr>
-        <p:spPr>
-          <a:xfrm>
-            <a:off x="340659" y="1650125"/>
-            <a:ext cx="10461812" cy="2386166"/>
-          </a:xfrm>
-          <a:prstGeom prst="rect">
-            <a:avLst/>
-          </a:prstGeom>
-          <a:solidFill>
-            <a:schemeClr val="accent1">
-              <a:alpha val="47000"/>
-            </a:schemeClr>
-          </a:solidFill>
-        </p:spPr>
-        <p:style>
-          <a:lnRef idx="2">
-            <a:schemeClr val="accent1">
-              <a:shade val="15000"/>
-            </a:schemeClr>
-          </a:lnRef>
-          <a:fillRef idx="1">
-            <a:schemeClr val="accent1"/>
-          </a:fillRef>
-          <a:effectRef idx="0">
-            <a:schemeClr val="accent1"/>
-          </a:effectRef>
-          <a:fontRef idx="minor">
-            <a:schemeClr val="lt1"/>
-          </a:fontRef>
-        </p:style>
-        <p:txBody>
-          <a:bodyPr rtlCol="0" anchor="ctr"/>
-          <a:lstStyle/>
-          <a:p>
-            <a:r>
-              <a:rPr lang="en-AU" dirty="0"/>
-              <a:t>Tenant</a:t>
-            </a:r>
-            <a:endParaRPr lang="en-US" dirty="0"/>
-          </a:p>
-        </p:txBody>
-      </p:sp>
-      <p:sp>
-        <p:nvSpPr>
-          <p:cNvPr id="5" name="Rectangle: Rounded Corners 4">
-            <a:extLst>
-              <a:ext uri="{FF2B5EF4-FFF2-40B4-BE49-F238E27FC236}">
-                <a16:creationId xmlns:a16="http://schemas.microsoft.com/office/drawing/2014/main" id="{333B4AA0-B3A0-58D3-C3A0-E4A3840A070D}"/>
-              </a:ext>
-            </a:extLst>
-          </p:cNvPr>
-          <p:cNvSpPr/>
-          <p:nvPr/>
-        </p:nvSpPr>
-        <p:spPr>
-          <a:xfrm>
-            <a:off x="7943030" y="377953"/>
-            <a:ext cx="2333296" cy="735726"/>
-          </a:xfrm>
-          <a:prstGeom prst="roundRect">
-            <a:avLst/>
-          </a:prstGeom>
-          <a:solidFill>
-            <a:schemeClr val="bg1">
-              <a:lumMod val="85000"/>
-              <a:alpha val="21000"/>
-            </a:schemeClr>
-          </a:solidFill>
-        </p:spPr>
-        <p:style>
-          <a:lnRef idx="2">
-            <a:schemeClr val="accent1">
-              <a:shade val="15000"/>
-            </a:schemeClr>
-          </a:lnRef>
-          <a:fillRef idx="1">
-            <a:schemeClr val="accent1"/>
-          </a:fillRef>
-          <a:effectRef idx="0">
-            <a:schemeClr val="accent1"/>
-          </a:effectRef>
-          <a:fontRef idx="minor">
-            <a:schemeClr val="lt1"/>
-          </a:fontRef>
-        </p:style>
-        <p:txBody>
-          <a:bodyPr rtlCol="0" anchor="ctr"/>
-          <a:lstStyle/>
-          <a:p>
-            <a:pPr algn="ctr"/>
-            <a:r>
-              <a:rPr lang="en-AU" sz="1600" dirty="0" err="1">
-                <a:solidFill>
-                  <a:schemeClr val="tx1"/>
-                </a:solidFill>
-              </a:rPr>
-              <a:t>BfsSystem</a:t>
-            </a:r>
-            <a:endParaRPr lang="en-US" sz="1600" dirty="0">
-              <a:solidFill>
-                <a:schemeClr val="tx1"/>
-              </a:solidFill>
-            </a:endParaRPr>
-          </a:p>
-        </p:txBody>
-      </p:sp>
-      <p:sp>
-        <p:nvSpPr>
-          <p:cNvPr id="7" name="Rectangle: Rounded Corners 6">
-            <a:extLst>
-              <a:ext uri="{FF2B5EF4-FFF2-40B4-BE49-F238E27FC236}">
-                <a16:creationId xmlns:a16="http://schemas.microsoft.com/office/drawing/2014/main" id="{EB30A78B-1428-398F-0328-F280D80AE345}"/>
-              </a:ext>
-            </a:extLst>
-          </p:cNvPr>
-          <p:cNvSpPr/>
-          <p:nvPr/>
-        </p:nvSpPr>
-        <p:spPr>
-          <a:xfrm>
-            <a:off x="8210884" y="1833058"/>
-            <a:ext cx="1801334" cy="392906"/>
-          </a:xfrm>
-          <a:prstGeom prst="roundRect">
-            <a:avLst/>
-          </a:prstGeom>
-          <a:solidFill>
-            <a:schemeClr val="accent1">
-              <a:alpha val="21000"/>
-            </a:schemeClr>
-          </a:solidFill>
-        </p:spPr>
-        <p:style>
-          <a:lnRef idx="2">
-            <a:schemeClr val="accent1">
-              <a:shade val="15000"/>
-            </a:schemeClr>
-          </a:lnRef>
-          <a:fillRef idx="1">
-            <a:schemeClr val="accent1"/>
-          </a:fillRef>
-          <a:effectRef idx="0">
-            <a:schemeClr val="accent1"/>
-          </a:effectRef>
-          <a:fontRef idx="minor">
-            <a:schemeClr val="lt1"/>
-          </a:fontRef>
-        </p:style>
-        <p:txBody>
-          <a:bodyPr rtlCol="0" anchor="ctr"/>
-          <a:lstStyle/>
-          <a:p>
-            <a:pPr algn="ctr"/>
-            <a:r>
-              <a:rPr lang="en-AU" sz="1600" dirty="0">
-                <a:solidFill>
-                  <a:schemeClr val="tx1"/>
-                </a:solidFill>
-              </a:rPr>
-              <a:t>Application</a:t>
-            </a:r>
-            <a:endParaRPr lang="en-US" sz="1600" dirty="0">
-              <a:solidFill>
-                <a:schemeClr val="tx1"/>
-              </a:solidFill>
-            </a:endParaRPr>
-          </a:p>
-        </p:txBody>
-      </p:sp>
-      <p:sp>
-        <p:nvSpPr>
-          <p:cNvPr id="9" name="Rectangle: Rounded Corners 8">
-            <a:extLst>
-              <a:ext uri="{FF2B5EF4-FFF2-40B4-BE49-F238E27FC236}">
-                <a16:creationId xmlns:a16="http://schemas.microsoft.com/office/drawing/2014/main" id="{F8260DF7-87C4-62F8-DD93-C902D73FE3BC}"/>
-              </a:ext>
-            </a:extLst>
-          </p:cNvPr>
-          <p:cNvSpPr/>
-          <p:nvPr/>
-        </p:nvSpPr>
-        <p:spPr>
-          <a:xfrm>
-            <a:off x="5449754" y="1833058"/>
-            <a:ext cx="1801334" cy="392906"/>
-          </a:xfrm>
-          <a:prstGeom prst="roundRect">
-            <a:avLst/>
-          </a:prstGeom>
-          <a:solidFill>
-            <a:schemeClr val="accent1">
-              <a:alpha val="21000"/>
-            </a:schemeClr>
-          </a:solidFill>
-        </p:spPr>
-        <p:style>
-          <a:lnRef idx="2">
-            <a:schemeClr val="accent1">
-              <a:shade val="15000"/>
-            </a:schemeClr>
-          </a:lnRef>
-          <a:fillRef idx="1">
-            <a:schemeClr val="accent1"/>
-          </a:fillRef>
-          <a:effectRef idx="0">
-            <a:schemeClr val="accent1"/>
-          </a:effectRef>
-          <a:fontRef idx="minor">
-            <a:schemeClr val="lt1"/>
-          </a:fontRef>
-        </p:style>
-        <p:txBody>
-          <a:bodyPr rtlCol="0" anchor="ctr"/>
-          <a:lstStyle/>
-          <a:p>
-            <a:pPr algn="ctr"/>
-            <a:r>
-              <a:rPr lang="en-AU" sz="1600" dirty="0">
-                <a:solidFill>
-                  <a:schemeClr val="tx1"/>
-                </a:solidFill>
-              </a:rPr>
-              <a:t>Role</a:t>
-            </a:r>
-            <a:endParaRPr lang="en-US" sz="1600" dirty="0">
-              <a:solidFill>
-                <a:schemeClr val="tx1"/>
-              </a:solidFill>
-            </a:endParaRPr>
-          </a:p>
-        </p:txBody>
-      </p:sp>
-      <p:sp>
-        <p:nvSpPr>
-          <p:cNvPr id="11" name="Rectangle: Rounded Corners 10">
-            <a:extLst>
-              <a:ext uri="{FF2B5EF4-FFF2-40B4-BE49-F238E27FC236}">
-                <a16:creationId xmlns:a16="http://schemas.microsoft.com/office/drawing/2014/main" id="{24E973F8-F2A6-E754-4836-B8AF676D186E}"/>
-              </a:ext>
-            </a:extLst>
-          </p:cNvPr>
-          <p:cNvSpPr/>
-          <p:nvPr/>
-        </p:nvSpPr>
-        <p:spPr>
-          <a:xfrm>
-            <a:off x="2570434" y="1833058"/>
-            <a:ext cx="1801334" cy="392906"/>
-          </a:xfrm>
-          <a:prstGeom prst="roundRect">
-            <a:avLst/>
-          </a:prstGeom>
-          <a:solidFill>
-            <a:schemeClr val="accent1">
-              <a:alpha val="21000"/>
-            </a:schemeClr>
-          </a:solidFill>
-        </p:spPr>
-        <p:style>
-          <a:lnRef idx="2">
-            <a:schemeClr val="accent1">
-              <a:shade val="15000"/>
-            </a:schemeClr>
-          </a:lnRef>
-          <a:fillRef idx="1">
-            <a:schemeClr val="accent1"/>
-          </a:fillRef>
-          <a:effectRef idx="0">
-            <a:schemeClr val="accent1"/>
-          </a:effectRef>
-          <a:fontRef idx="minor">
-            <a:schemeClr val="lt1"/>
-          </a:fontRef>
-        </p:style>
-        <p:txBody>
-          <a:bodyPr rtlCol="0" anchor="ctr"/>
-          <a:lstStyle/>
-          <a:p>
-            <a:pPr algn="ctr"/>
-            <a:r>
-              <a:rPr lang="en-AU" sz="1600" dirty="0">
-                <a:solidFill>
-                  <a:schemeClr val="tx1"/>
-                </a:solidFill>
-              </a:rPr>
-              <a:t>User</a:t>
-            </a:r>
-            <a:endParaRPr lang="en-US" sz="1600" dirty="0">
-              <a:solidFill>
-                <a:schemeClr val="tx1"/>
-              </a:solidFill>
-            </a:endParaRPr>
-          </a:p>
-        </p:txBody>
-      </p:sp>
-      <p:sp>
-        <p:nvSpPr>
-          <p:cNvPr id="24" name="Rectangle: Rounded Corners 23">
-            <a:extLst>
-              <a:ext uri="{FF2B5EF4-FFF2-40B4-BE49-F238E27FC236}">
-                <a16:creationId xmlns:a16="http://schemas.microsoft.com/office/drawing/2014/main" id="{2199673F-629D-5CAF-93C6-E8854CCD81D2}"/>
-              </a:ext>
-            </a:extLst>
-          </p:cNvPr>
-          <p:cNvSpPr/>
-          <p:nvPr/>
-        </p:nvSpPr>
-        <p:spPr>
-          <a:xfrm>
-            <a:off x="5181900" y="388231"/>
-            <a:ext cx="2333296" cy="735726"/>
-          </a:xfrm>
-          <a:prstGeom prst="roundRect">
-            <a:avLst/>
-          </a:prstGeom>
-          <a:solidFill>
-            <a:schemeClr val="bg1">
-              <a:lumMod val="85000"/>
-              <a:alpha val="21000"/>
-            </a:schemeClr>
-          </a:solidFill>
-        </p:spPr>
-        <p:style>
-          <a:lnRef idx="2">
-            <a:schemeClr val="accent1">
-              <a:shade val="15000"/>
-            </a:schemeClr>
-          </a:lnRef>
-          <a:fillRef idx="1">
-            <a:schemeClr val="accent1"/>
-          </a:fillRef>
-          <a:effectRef idx="0">
-            <a:schemeClr val="accent1"/>
-          </a:effectRef>
-          <a:fontRef idx="minor">
-            <a:schemeClr val="lt1"/>
-          </a:fontRef>
-        </p:style>
-        <p:txBody>
-          <a:bodyPr rtlCol="0" anchor="ctr"/>
-          <a:lstStyle/>
-          <a:p>
-            <a:pPr algn="ctr"/>
-            <a:r>
-              <a:rPr lang="en-AU" sz="1600" dirty="0" err="1">
-                <a:solidFill>
-                  <a:schemeClr val="tx1"/>
-                </a:solidFill>
-              </a:rPr>
-              <a:t>BfsTenant</a:t>
-            </a:r>
-            <a:endParaRPr lang="en-US" sz="1600" dirty="0">
-              <a:solidFill>
-                <a:schemeClr val="tx1"/>
-              </a:solidFill>
-            </a:endParaRPr>
-          </a:p>
-        </p:txBody>
-      </p:sp>
-      <p:sp>
-        <p:nvSpPr>
-          <p:cNvPr id="26" name="Rectangle: Rounded Corners 25">
-            <a:extLst>
-              <a:ext uri="{FF2B5EF4-FFF2-40B4-BE49-F238E27FC236}">
-                <a16:creationId xmlns:a16="http://schemas.microsoft.com/office/drawing/2014/main" id="{F410340E-C040-3537-89DE-8B5C317E0055}"/>
-              </a:ext>
-            </a:extLst>
-          </p:cNvPr>
-          <p:cNvSpPr/>
-          <p:nvPr/>
-        </p:nvSpPr>
-        <p:spPr>
-          <a:xfrm>
-            <a:off x="2279495" y="388231"/>
-            <a:ext cx="2333296" cy="735726"/>
-          </a:xfrm>
-          <a:prstGeom prst="roundRect">
-            <a:avLst/>
-          </a:prstGeom>
-          <a:solidFill>
-            <a:schemeClr val="bg1">
-              <a:lumMod val="85000"/>
-              <a:alpha val="21000"/>
-            </a:schemeClr>
-          </a:solidFill>
-        </p:spPr>
-        <p:style>
-          <a:lnRef idx="2">
-            <a:schemeClr val="accent1">
-              <a:shade val="15000"/>
-            </a:schemeClr>
-          </a:lnRef>
-          <a:fillRef idx="1">
-            <a:schemeClr val="accent1"/>
-          </a:fillRef>
-          <a:effectRef idx="0">
-            <a:schemeClr val="accent1"/>
-          </a:effectRef>
-          <a:fontRef idx="minor">
-            <a:schemeClr val="lt1"/>
-          </a:fontRef>
-        </p:style>
-        <p:txBody>
-          <a:bodyPr rtlCol="0" anchor="ctr"/>
-          <a:lstStyle/>
-          <a:p>
-            <a:pPr algn="ctr"/>
-            <a:r>
-              <a:rPr lang="en-AU" sz="1600" dirty="0" err="1">
-                <a:solidFill>
-                  <a:schemeClr val="tx1"/>
-                </a:solidFill>
-              </a:rPr>
-              <a:t>AspNetUser</a:t>
-            </a:r>
-            <a:endParaRPr lang="en-US" sz="1600" dirty="0">
-              <a:solidFill>
-                <a:schemeClr val="tx1"/>
-              </a:solidFill>
-            </a:endParaRPr>
-          </a:p>
-        </p:txBody>
-      </p:sp>
-      <p:cxnSp>
-        <p:nvCxnSpPr>
-          <p:cNvPr id="28" name="Straight Arrow Connector 27">
-            <a:extLst>
-              <a:ext uri="{FF2B5EF4-FFF2-40B4-BE49-F238E27FC236}">
-                <a16:creationId xmlns:a16="http://schemas.microsoft.com/office/drawing/2014/main" id="{42B2A66F-60C1-BAF0-54E7-7A86C4DB40A6}"/>
-              </a:ext>
-            </a:extLst>
-          </p:cNvPr>
-          <p:cNvCxnSpPr>
-            <a:cxnSpLocks/>
-            <a:stCxn id="26" idx="2"/>
-            <a:endCxn id="11" idx="0"/>
-          </p:cNvCxnSpPr>
-          <p:nvPr/>
-        </p:nvCxnSpPr>
-        <p:spPr>
-          <a:xfrm>
-            <a:off x="3446143" y="1123957"/>
-            <a:ext cx="24958" cy="709101"/>
-          </a:xfrm>
-          <a:prstGeom prst="straightConnector1">
-            <a:avLst/>
-          </a:prstGeom>
-          <a:ln>
-            <a:tailEnd type="triangle"/>
-          </a:ln>
-        </p:spPr>
-        <p:style>
-          <a:lnRef idx="2">
-            <a:schemeClr val="accent1"/>
-          </a:lnRef>
-          <a:fillRef idx="0">
-            <a:schemeClr val="accent1"/>
-          </a:fillRef>
-          <a:effectRef idx="1">
-            <a:schemeClr val="accent1"/>
-          </a:effectRef>
-          <a:fontRef idx="minor">
-            <a:schemeClr val="tx1"/>
-          </a:fontRef>
-        </p:style>
-      </p:cxnSp>
-      <p:sp>
-        <p:nvSpPr>
-          <p:cNvPr id="41" name="Rectangle: Rounded Corners 40">
-            <a:extLst>
-              <a:ext uri="{FF2B5EF4-FFF2-40B4-BE49-F238E27FC236}">
-                <a16:creationId xmlns:a16="http://schemas.microsoft.com/office/drawing/2014/main" id="{80892785-EB90-D2EE-A1A2-AF2628C53879}"/>
-              </a:ext>
-            </a:extLst>
-          </p:cNvPr>
-          <p:cNvSpPr/>
-          <p:nvPr/>
-        </p:nvSpPr>
-        <p:spPr>
-          <a:xfrm>
-            <a:off x="8210884" y="2583692"/>
-            <a:ext cx="1801334" cy="392906"/>
-          </a:xfrm>
-          <a:prstGeom prst="roundRect">
-            <a:avLst/>
-          </a:prstGeom>
-          <a:solidFill>
-            <a:schemeClr val="accent2">
-              <a:alpha val="21000"/>
-            </a:schemeClr>
-          </a:solidFill>
-        </p:spPr>
-        <p:style>
-          <a:lnRef idx="2">
-            <a:schemeClr val="accent1">
-              <a:shade val="15000"/>
-            </a:schemeClr>
-          </a:lnRef>
-          <a:fillRef idx="1">
-            <a:schemeClr val="accent1"/>
-          </a:fillRef>
-          <a:effectRef idx="0">
-            <a:schemeClr val="accent1"/>
-          </a:effectRef>
-          <a:fontRef idx="minor">
-            <a:schemeClr val="lt1"/>
-          </a:fontRef>
-        </p:style>
-        <p:txBody>
-          <a:bodyPr rtlCol="0" anchor="ctr"/>
-          <a:lstStyle/>
-          <a:p>
-            <a:pPr algn="ctr"/>
-            <a:r>
-              <a:rPr lang="en-AU" sz="1600" dirty="0">
-                <a:solidFill>
-                  <a:schemeClr val="tx1"/>
-                </a:solidFill>
-              </a:rPr>
-              <a:t>Investor</a:t>
-            </a:r>
-            <a:endParaRPr lang="en-US" sz="1600" dirty="0">
-              <a:solidFill>
-                <a:schemeClr val="tx1"/>
-              </a:solidFill>
-            </a:endParaRPr>
-          </a:p>
-        </p:txBody>
-      </p:sp>
-      <p:sp>
-        <p:nvSpPr>
-          <p:cNvPr id="43" name="Rectangle: Rounded Corners 42">
-            <a:extLst>
-              <a:ext uri="{FF2B5EF4-FFF2-40B4-BE49-F238E27FC236}">
-                <a16:creationId xmlns:a16="http://schemas.microsoft.com/office/drawing/2014/main" id="{EA2B2F91-742F-0386-4935-6AFD88BBBFA6}"/>
-              </a:ext>
-            </a:extLst>
-          </p:cNvPr>
-          <p:cNvSpPr/>
-          <p:nvPr/>
-        </p:nvSpPr>
-        <p:spPr>
-          <a:xfrm>
-            <a:off x="5449754" y="2583692"/>
-            <a:ext cx="1801334" cy="392906"/>
-          </a:xfrm>
-          <a:prstGeom prst="roundRect">
-            <a:avLst/>
-          </a:prstGeom>
-          <a:solidFill>
-            <a:schemeClr val="accent2">
-              <a:alpha val="21000"/>
-            </a:schemeClr>
-          </a:solidFill>
-        </p:spPr>
-        <p:style>
-          <a:lnRef idx="2">
-            <a:schemeClr val="accent1">
-              <a:shade val="15000"/>
-            </a:schemeClr>
-          </a:lnRef>
-          <a:fillRef idx="1">
-            <a:schemeClr val="accent1"/>
-          </a:fillRef>
-          <a:effectRef idx="0">
-            <a:schemeClr val="accent1"/>
-          </a:effectRef>
-          <a:fontRef idx="minor">
-            <a:schemeClr val="lt1"/>
-          </a:fontRef>
-        </p:style>
-        <p:txBody>
-          <a:bodyPr rtlCol="0" anchor="ctr"/>
-          <a:lstStyle/>
-          <a:p>
-            <a:pPr algn="ctr"/>
-            <a:r>
-              <a:rPr lang="en-AU" sz="1600" dirty="0">
-                <a:solidFill>
-                  <a:schemeClr val="tx1"/>
-                </a:solidFill>
-              </a:rPr>
-              <a:t>Broker</a:t>
-            </a:r>
-            <a:endParaRPr lang="en-US" sz="1600" dirty="0">
-              <a:solidFill>
-                <a:schemeClr val="tx1"/>
-              </a:solidFill>
-            </a:endParaRPr>
-          </a:p>
-        </p:txBody>
-      </p:sp>
-      <p:sp>
-        <p:nvSpPr>
-          <p:cNvPr id="45" name="Rectangle: Rounded Corners 44">
-            <a:extLst>
-              <a:ext uri="{FF2B5EF4-FFF2-40B4-BE49-F238E27FC236}">
-                <a16:creationId xmlns:a16="http://schemas.microsoft.com/office/drawing/2014/main" id="{A433504C-268F-B8E1-9745-46D47F062BA1}"/>
-              </a:ext>
-            </a:extLst>
-          </p:cNvPr>
-          <p:cNvSpPr/>
-          <p:nvPr/>
-        </p:nvSpPr>
-        <p:spPr>
-          <a:xfrm>
-            <a:off x="2570434" y="2583692"/>
-            <a:ext cx="1801334" cy="392906"/>
-          </a:xfrm>
-          <a:prstGeom prst="roundRect">
-            <a:avLst/>
-          </a:prstGeom>
-          <a:solidFill>
-            <a:schemeClr val="accent2">
-              <a:alpha val="21000"/>
-            </a:schemeClr>
-          </a:solidFill>
-        </p:spPr>
-        <p:style>
-          <a:lnRef idx="2">
-            <a:schemeClr val="accent1">
-              <a:shade val="15000"/>
-            </a:schemeClr>
-          </a:lnRef>
-          <a:fillRef idx="1">
-            <a:schemeClr val="accent1"/>
-          </a:fillRef>
-          <a:effectRef idx="0">
-            <a:schemeClr val="accent1"/>
-          </a:effectRef>
-          <a:fontRef idx="minor">
-            <a:schemeClr val="lt1"/>
-          </a:fontRef>
-        </p:style>
-        <p:txBody>
-          <a:bodyPr rtlCol="0" anchor="ctr"/>
-          <a:lstStyle/>
-          <a:p>
-            <a:pPr algn="ctr"/>
-            <a:r>
-              <a:rPr lang="en-AU" sz="1600" dirty="0" err="1">
-                <a:solidFill>
-                  <a:schemeClr val="tx1"/>
-                </a:solidFill>
-              </a:rPr>
-              <a:t>TradingRoom</a:t>
-            </a:r>
-            <a:endParaRPr lang="en-US" sz="1600" dirty="0">
-              <a:solidFill>
-                <a:schemeClr val="tx1"/>
-              </a:solidFill>
-            </a:endParaRPr>
-          </a:p>
-        </p:txBody>
-      </p:sp>
-      <p:sp>
-        <p:nvSpPr>
-          <p:cNvPr id="47" name="Rectangle: Rounded Corners 46">
-            <a:extLst>
-              <a:ext uri="{FF2B5EF4-FFF2-40B4-BE49-F238E27FC236}">
-                <a16:creationId xmlns:a16="http://schemas.microsoft.com/office/drawing/2014/main" id="{DECB229A-5988-5AB3-BD89-C40E3C4E1E00}"/>
-              </a:ext>
-            </a:extLst>
-          </p:cNvPr>
-          <p:cNvSpPr/>
-          <p:nvPr/>
-        </p:nvSpPr>
-        <p:spPr>
-          <a:xfrm>
-            <a:off x="8210884" y="3334326"/>
-            <a:ext cx="1801334" cy="392906"/>
-          </a:xfrm>
-          <a:prstGeom prst="roundRect">
-            <a:avLst/>
-          </a:prstGeom>
-          <a:solidFill>
-            <a:srgbClr val="FF0000">
-              <a:alpha val="21000"/>
-            </a:srgbClr>
-          </a:solidFill>
-        </p:spPr>
-        <p:style>
-          <a:lnRef idx="2">
-            <a:schemeClr val="accent1">
-              <a:shade val="15000"/>
-            </a:schemeClr>
-          </a:lnRef>
-          <a:fillRef idx="1">
-            <a:schemeClr val="accent1"/>
-          </a:fillRef>
-          <a:effectRef idx="0">
-            <a:schemeClr val="accent1"/>
-          </a:effectRef>
-          <a:fontRef idx="minor">
-            <a:schemeClr val="lt1"/>
-          </a:fontRef>
-        </p:style>
-        <p:txBody>
-          <a:bodyPr rtlCol="0" anchor="ctr"/>
-          <a:lstStyle/>
-          <a:p>
-            <a:pPr algn="ctr"/>
-            <a:r>
-              <a:rPr lang="en-AU" sz="1600" dirty="0" err="1">
-                <a:solidFill>
-                  <a:schemeClr val="tx1"/>
-                </a:solidFill>
-              </a:rPr>
-              <a:t>MonthlyItem</a:t>
-            </a:r>
-            <a:endParaRPr lang="en-US" sz="1600" dirty="0">
-              <a:solidFill>
-                <a:schemeClr val="tx1"/>
-              </a:solidFill>
-            </a:endParaRPr>
-          </a:p>
-        </p:txBody>
-      </p:sp>
-      <p:sp>
-        <p:nvSpPr>
-          <p:cNvPr id="49" name="Rectangle: Rounded Corners 48">
-            <a:extLst>
-              <a:ext uri="{FF2B5EF4-FFF2-40B4-BE49-F238E27FC236}">
-                <a16:creationId xmlns:a16="http://schemas.microsoft.com/office/drawing/2014/main" id="{7173D389-5470-FEB4-A7DA-5DD0365B556B}"/>
-              </a:ext>
-            </a:extLst>
-          </p:cNvPr>
-          <p:cNvSpPr/>
-          <p:nvPr/>
-        </p:nvSpPr>
-        <p:spPr>
-          <a:xfrm>
-            <a:off x="5449754" y="3334326"/>
-            <a:ext cx="1801334" cy="392906"/>
-          </a:xfrm>
-          <a:prstGeom prst="roundRect">
-            <a:avLst/>
-          </a:prstGeom>
-          <a:solidFill>
-            <a:srgbClr val="FF0000">
-              <a:alpha val="21000"/>
-            </a:srgbClr>
-          </a:solidFill>
-        </p:spPr>
-        <p:style>
-          <a:lnRef idx="2">
-            <a:schemeClr val="accent1">
-              <a:shade val="15000"/>
-            </a:schemeClr>
-          </a:lnRef>
-          <a:fillRef idx="1">
-            <a:schemeClr val="accent1"/>
-          </a:fillRef>
-          <a:effectRef idx="0">
-            <a:schemeClr val="accent1"/>
-          </a:effectRef>
-          <a:fontRef idx="minor">
-            <a:schemeClr val="lt1"/>
-          </a:fontRef>
-        </p:style>
-        <p:txBody>
-          <a:bodyPr rtlCol="0" anchor="ctr"/>
-          <a:lstStyle/>
-          <a:p>
-            <a:pPr algn="ctr"/>
-            <a:r>
-              <a:rPr lang="en-AU" sz="1600" dirty="0" err="1">
-                <a:solidFill>
-                  <a:schemeClr val="tx1"/>
-                </a:solidFill>
-              </a:rPr>
-              <a:t>SalaryItem</a:t>
-            </a:r>
-            <a:endParaRPr lang="en-US" sz="1600" dirty="0">
-              <a:solidFill>
-                <a:schemeClr val="tx1"/>
-              </a:solidFill>
-            </a:endParaRPr>
-          </a:p>
-        </p:txBody>
-      </p:sp>
-      <p:sp>
-        <p:nvSpPr>
-          <p:cNvPr id="51" name="Rectangle: Rounded Corners 50">
-            <a:extLst>
-              <a:ext uri="{FF2B5EF4-FFF2-40B4-BE49-F238E27FC236}">
-                <a16:creationId xmlns:a16="http://schemas.microsoft.com/office/drawing/2014/main" id="{DA1C6CAD-7557-E477-9FB2-780D252A439F}"/>
-              </a:ext>
-            </a:extLst>
-          </p:cNvPr>
-          <p:cNvSpPr/>
-          <p:nvPr/>
-        </p:nvSpPr>
-        <p:spPr>
-          <a:xfrm>
-            <a:off x="2570434" y="3334326"/>
-            <a:ext cx="1801334" cy="392906"/>
-          </a:xfrm>
-          <a:prstGeom prst="roundRect">
-            <a:avLst/>
-          </a:prstGeom>
-          <a:solidFill>
-            <a:srgbClr val="FF0000">
-              <a:alpha val="21000"/>
-            </a:srgbClr>
-          </a:solidFill>
-        </p:spPr>
-        <p:style>
-          <a:lnRef idx="2">
-            <a:schemeClr val="accent1">
-              <a:shade val="15000"/>
-            </a:schemeClr>
-          </a:lnRef>
-          <a:fillRef idx="1">
-            <a:schemeClr val="accent1"/>
-          </a:fillRef>
-          <a:effectRef idx="0">
-            <a:schemeClr val="accent1"/>
-          </a:effectRef>
-          <a:fontRef idx="minor">
-            <a:schemeClr val="lt1"/>
-          </a:fontRef>
-        </p:style>
-        <p:txBody>
-          <a:bodyPr rtlCol="0" anchor="ctr"/>
-          <a:lstStyle/>
-          <a:p>
-            <a:pPr algn="ctr"/>
-            <a:r>
-              <a:rPr lang="en-AU" sz="1600" dirty="0">
-                <a:solidFill>
-                  <a:schemeClr val="tx1"/>
-                </a:solidFill>
-              </a:rPr>
-              <a:t>Employee</a:t>
-            </a:r>
-            <a:endParaRPr lang="en-US" sz="1600" dirty="0">
-              <a:solidFill>
-                <a:schemeClr val="tx1"/>
-              </a:solidFill>
-            </a:endParaRPr>
-          </a:p>
-        </p:txBody>
-      </p:sp>
-      <p:sp>
-        <p:nvSpPr>
-          <p:cNvPr id="52" name="Scroll: Vertical 51">
-            <a:extLst>
-              <a:ext uri="{FF2B5EF4-FFF2-40B4-BE49-F238E27FC236}">
-                <a16:creationId xmlns:a16="http://schemas.microsoft.com/office/drawing/2014/main" id="{F6C59AFF-B60A-EC42-4110-AF09023C18A6}"/>
-              </a:ext>
-            </a:extLst>
-          </p:cNvPr>
-          <p:cNvSpPr/>
-          <p:nvPr/>
-        </p:nvSpPr>
-        <p:spPr>
-          <a:xfrm>
-            <a:off x="1736436" y="1833058"/>
-            <a:ext cx="443346" cy="392906"/>
-          </a:xfrm>
-          <a:prstGeom prst="verticalScroll">
-            <a:avLst/>
-          </a:prstGeom>
-        </p:spPr>
-        <p:style>
-          <a:lnRef idx="2">
-            <a:schemeClr val="accent1">
-              <a:shade val="15000"/>
-            </a:schemeClr>
-          </a:lnRef>
-          <a:fillRef idx="1">
-            <a:schemeClr val="accent1"/>
-          </a:fillRef>
-          <a:effectRef idx="0">
-            <a:schemeClr val="accent1"/>
-          </a:effectRef>
-          <a:fontRef idx="minor">
-            <a:schemeClr val="lt1"/>
-          </a:fontRef>
-        </p:style>
-        <p:txBody>
-          <a:bodyPr rtlCol="0" anchor="ctr"/>
-          <a:lstStyle/>
-          <a:p>
-            <a:pPr algn="ctr"/>
-            <a:endParaRPr lang="en-US"/>
-          </a:p>
-        </p:txBody>
-      </p:sp>
-      <p:sp>
-        <p:nvSpPr>
-          <p:cNvPr id="54" name="Scroll: Vertical 53">
-            <a:extLst>
-              <a:ext uri="{FF2B5EF4-FFF2-40B4-BE49-F238E27FC236}">
-                <a16:creationId xmlns:a16="http://schemas.microsoft.com/office/drawing/2014/main" id="{E6A38B9F-D8A5-7A81-ACE1-58AAD136423B}"/>
-              </a:ext>
-            </a:extLst>
-          </p:cNvPr>
-          <p:cNvSpPr/>
-          <p:nvPr/>
-        </p:nvSpPr>
-        <p:spPr>
-          <a:xfrm>
-            <a:off x="1789967" y="2542825"/>
-            <a:ext cx="443346" cy="392906"/>
-          </a:xfrm>
-          <a:prstGeom prst="verticalScroll">
-            <a:avLst/>
-          </a:prstGeom>
-        </p:spPr>
-        <p:style>
-          <a:lnRef idx="2">
-            <a:schemeClr val="accent1">
-              <a:shade val="15000"/>
-            </a:schemeClr>
-          </a:lnRef>
-          <a:fillRef idx="1">
-            <a:schemeClr val="accent1"/>
-          </a:fillRef>
-          <a:effectRef idx="0">
-            <a:schemeClr val="accent1"/>
-          </a:effectRef>
-          <a:fontRef idx="minor">
-            <a:schemeClr val="lt1"/>
-          </a:fontRef>
-        </p:style>
-        <p:txBody>
-          <a:bodyPr rtlCol="0" anchor="ctr"/>
-          <a:lstStyle/>
-          <a:p>
-            <a:pPr algn="ctr"/>
-            <a:endParaRPr lang="en-US"/>
-          </a:p>
-        </p:txBody>
-      </p:sp>
-      <p:sp>
-        <p:nvSpPr>
-          <p:cNvPr id="56" name="Scroll: Vertical 55">
-            <a:extLst>
-              <a:ext uri="{FF2B5EF4-FFF2-40B4-BE49-F238E27FC236}">
-                <a16:creationId xmlns:a16="http://schemas.microsoft.com/office/drawing/2014/main" id="{A3B48AED-67C8-DEFB-1743-FEDCB0885FE7}"/>
-              </a:ext>
-            </a:extLst>
-          </p:cNvPr>
-          <p:cNvSpPr/>
-          <p:nvPr/>
-        </p:nvSpPr>
-        <p:spPr>
-          <a:xfrm>
-            <a:off x="1789967" y="3334326"/>
-            <a:ext cx="443346" cy="392906"/>
-          </a:xfrm>
-          <a:prstGeom prst="verticalScroll">
-            <a:avLst/>
-          </a:prstGeom>
-        </p:spPr>
-        <p:style>
-          <a:lnRef idx="2">
-            <a:schemeClr val="accent1">
-              <a:shade val="15000"/>
-            </a:schemeClr>
-          </a:lnRef>
-          <a:fillRef idx="1">
-            <a:schemeClr val="accent1"/>
-          </a:fillRef>
-          <a:effectRef idx="0">
-            <a:schemeClr val="accent1"/>
-          </a:effectRef>
-          <a:fontRef idx="minor">
-            <a:schemeClr val="lt1"/>
-          </a:fontRef>
-        </p:style>
-        <p:txBody>
-          <a:bodyPr rtlCol="0" anchor="ctr"/>
-          <a:lstStyle/>
-          <a:p>
-            <a:pPr algn="ctr"/>
-            <a:endParaRPr lang="en-US"/>
-          </a:p>
-        </p:txBody>
-      </p:sp>
-      <p:sp>
-        <p:nvSpPr>
-          <p:cNvPr id="58" name="Scroll: Vertical 57">
-            <a:extLst>
-              <a:ext uri="{FF2B5EF4-FFF2-40B4-BE49-F238E27FC236}">
-                <a16:creationId xmlns:a16="http://schemas.microsoft.com/office/drawing/2014/main" id="{640DC75B-08C6-212C-1AAE-126C11DB511C}"/>
-              </a:ext>
-            </a:extLst>
-          </p:cNvPr>
-          <p:cNvSpPr/>
-          <p:nvPr/>
-        </p:nvSpPr>
-        <p:spPr>
-          <a:xfrm>
-            <a:off x="90475" y="4513354"/>
-            <a:ext cx="2978965" cy="2210719"/>
-          </a:xfrm>
-          <a:prstGeom prst="verticalScroll">
-            <a:avLst/>
-          </a:prstGeom>
-        </p:spPr>
-        <p:style>
-          <a:lnRef idx="2">
-            <a:schemeClr val="accent1">
-              <a:shade val="15000"/>
-            </a:schemeClr>
-          </a:lnRef>
-          <a:fillRef idx="1">
-            <a:schemeClr val="accent1"/>
-          </a:fillRef>
-          <a:effectRef idx="0">
-            <a:schemeClr val="accent1"/>
-          </a:effectRef>
-          <a:fontRef idx="minor">
-            <a:schemeClr val="lt1"/>
-          </a:fontRef>
-        </p:style>
-        <p:txBody>
-          <a:bodyPr rtlCol="0" anchor="ctr"/>
-          <a:lstStyle/>
-          <a:p>
-            <a:pPr algn="ctr"/>
-            <a:r>
-              <a:rPr lang="en-AU" dirty="0" err="1"/>
-              <a:t>MenuItem</a:t>
-            </a:r>
-            <a:endParaRPr lang="en-US" dirty="0"/>
-          </a:p>
-        </p:txBody>
-      </p:sp>
-      <p:sp>
-        <p:nvSpPr>
-          <p:cNvPr id="60" name="Rectangle: Rounded Corners 59">
-            <a:extLst>
-              <a:ext uri="{FF2B5EF4-FFF2-40B4-BE49-F238E27FC236}">
-                <a16:creationId xmlns:a16="http://schemas.microsoft.com/office/drawing/2014/main" id="{1F04ECC2-2618-4660-9F5B-A1B884E4CD4F}"/>
-              </a:ext>
-            </a:extLst>
-          </p:cNvPr>
-          <p:cNvSpPr/>
-          <p:nvPr/>
-        </p:nvSpPr>
-        <p:spPr>
-          <a:xfrm>
-            <a:off x="4081578" y="5537590"/>
-            <a:ext cx="1220394" cy="392906"/>
-          </a:xfrm>
-          <a:prstGeom prst="roundRect">
-            <a:avLst/>
-          </a:prstGeom>
-          <a:solidFill>
-            <a:schemeClr val="accent1">
-              <a:alpha val="21000"/>
-            </a:schemeClr>
-          </a:solidFill>
-        </p:spPr>
-        <p:style>
-          <a:lnRef idx="2">
-            <a:schemeClr val="accent1">
-              <a:shade val="15000"/>
-            </a:schemeClr>
-          </a:lnRef>
-          <a:fillRef idx="1">
-            <a:schemeClr val="accent1"/>
-          </a:fillRef>
-          <a:effectRef idx="0">
-            <a:schemeClr val="accent1"/>
-          </a:effectRef>
-          <a:fontRef idx="minor">
-            <a:schemeClr val="lt1"/>
-          </a:fontRef>
-        </p:style>
-        <p:txBody>
-          <a:bodyPr rtlCol="0" anchor="ctr"/>
-          <a:lstStyle/>
-          <a:p>
-            <a:pPr algn="ctr"/>
-            <a:r>
-              <a:rPr lang="en-AU" sz="1400" dirty="0">
-                <a:solidFill>
-                  <a:schemeClr val="tx1"/>
-                </a:solidFill>
-              </a:rPr>
-              <a:t>Application</a:t>
-            </a:r>
-            <a:endParaRPr lang="en-US" sz="1400" dirty="0">
-              <a:solidFill>
-                <a:schemeClr val="tx1"/>
-              </a:solidFill>
-            </a:endParaRPr>
-          </a:p>
-        </p:txBody>
-      </p:sp>
-      <p:sp>
-        <p:nvSpPr>
-          <p:cNvPr id="62" name="Rectangle: Rounded Corners 61">
-            <a:extLst>
-              <a:ext uri="{FF2B5EF4-FFF2-40B4-BE49-F238E27FC236}">
-                <a16:creationId xmlns:a16="http://schemas.microsoft.com/office/drawing/2014/main" id="{541E2CE8-0378-5B6E-D4E0-9F176614F40E}"/>
-              </a:ext>
-            </a:extLst>
-          </p:cNvPr>
-          <p:cNvSpPr/>
-          <p:nvPr/>
-        </p:nvSpPr>
-        <p:spPr>
-          <a:xfrm>
-            <a:off x="2823268" y="5537590"/>
-            <a:ext cx="1220394" cy="392906"/>
-          </a:xfrm>
-          <a:prstGeom prst="roundRect">
-            <a:avLst/>
-          </a:prstGeom>
-          <a:solidFill>
-            <a:schemeClr val="accent1">
-              <a:alpha val="21000"/>
-            </a:schemeClr>
-          </a:solidFill>
-        </p:spPr>
-        <p:style>
-          <a:lnRef idx="2">
-            <a:schemeClr val="accent1">
-              <a:shade val="15000"/>
-            </a:schemeClr>
-          </a:lnRef>
-          <a:fillRef idx="1">
-            <a:schemeClr val="accent1"/>
-          </a:fillRef>
-          <a:effectRef idx="0">
-            <a:schemeClr val="accent1"/>
-          </a:effectRef>
-          <a:fontRef idx="minor">
-            <a:schemeClr val="lt1"/>
-          </a:fontRef>
-        </p:style>
-        <p:txBody>
-          <a:bodyPr rtlCol="0" anchor="ctr"/>
-          <a:lstStyle/>
-          <a:p>
-            <a:pPr algn="ctr"/>
-            <a:r>
-              <a:rPr lang="en-AU" sz="1400" dirty="0">
-                <a:solidFill>
-                  <a:schemeClr val="tx1"/>
-                </a:solidFill>
-              </a:rPr>
-              <a:t>Role</a:t>
-            </a:r>
-            <a:endParaRPr lang="en-US" sz="1400" dirty="0">
-              <a:solidFill>
-                <a:schemeClr val="tx1"/>
-              </a:solidFill>
-            </a:endParaRPr>
-          </a:p>
-        </p:txBody>
-      </p:sp>
-      <p:pic>
-        <p:nvPicPr>
-          <p:cNvPr id="64" name="Graphic 63" descr="Programmer male outline">
-            <a:extLst>
-              <a:ext uri="{FF2B5EF4-FFF2-40B4-BE49-F238E27FC236}">
-                <a16:creationId xmlns:a16="http://schemas.microsoft.com/office/drawing/2014/main" id="{CC7F26EA-1F0D-F9E2-3B28-3240CBC0AA59}"/>
-              </a:ext>
-            </a:extLst>
-          </p:cNvPr>
-          <p:cNvPicPr>
-            <a:picLocks noChangeAspect="1"/>
-          </p:cNvPicPr>
-          <p:nvPr/>
-        </p:nvPicPr>
-        <p:blipFill>
-          <a:blip>
-            <a:extLst>
-              <a:ext uri="{96DAC541-7B7A-43D3-8B79-37D633B846F1}">
-                <asvg:svgBlip xmlns:asvg="http://schemas.microsoft.com/office/drawing/2016/SVG/main" r:embed="rId2"/>
-              </a:ext>
-            </a:extLst>
-          </a:blip>
-          <a:stretch>
-            <a:fillRect/>
-          </a:stretch>
-        </p:blipFill>
-        <p:spPr>
-          <a:xfrm>
-            <a:off x="9276110" y="4293158"/>
-            <a:ext cx="2255545" cy="2255545"/>
-          </a:xfrm>
-          <a:prstGeom prst="rect">
-            <a:avLst/>
-          </a:prstGeom>
-          <a:effectLst>
-            <a:outerShdw blurRad="50800" dist="127000" dir="2700000" algn="tl" rotWithShape="0">
-              <a:schemeClr val="accent1">
-                <a:alpha val="40000"/>
-              </a:schemeClr>
-            </a:outerShdw>
-          </a:effectLst>
-        </p:spPr>
-      </p:pic>
-      <p:sp>
-        <p:nvSpPr>
-          <p:cNvPr id="66" name="Rectangle: Rounded Corners 65">
-            <a:extLst>
-              <a:ext uri="{FF2B5EF4-FFF2-40B4-BE49-F238E27FC236}">
-                <a16:creationId xmlns:a16="http://schemas.microsoft.com/office/drawing/2014/main" id="{6BB1E8C6-ACD2-D8C8-000F-C8EF8B1241FC}"/>
-              </a:ext>
-            </a:extLst>
-          </p:cNvPr>
-          <p:cNvSpPr/>
-          <p:nvPr/>
-        </p:nvSpPr>
-        <p:spPr>
-          <a:xfrm>
-            <a:off x="8481989" y="5537590"/>
-            <a:ext cx="1220394" cy="392906"/>
-          </a:xfrm>
-          <a:prstGeom prst="roundRect">
-            <a:avLst/>
-          </a:prstGeom>
-          <a:solidFill>
-            <a:schemeClr val="accent1">
-              <a:alpha val="21000"/>
-            </a:schemeClr>
-          </a:solidFill>
-        </p:spPr>
-        <p:style>
-          <a:lnRef idx="2">
-            <a:schemeClr val="accent1">
-              <a:shade val="15000"/>
-            </a:schemeClr>
-          </a:lnRef>
-          <a:fillRef idx="1">
-            <a:schemeClr val="accent1"/>
-          </a:fillRef>
-          <a:effectRef idx="0">
-            <a:schemeClr val="accent1"/>
-          </a:effectRef>
-          <a:fontRef idx="minor">
-            <a:schemeClr val="lt1"/>
-          </a:fontRef>
-        </p:style>
-        <p:txBody>
-          <a:bodyPr rtlCol="0" anchor="ctr"/>
-          <a:lstStyle/>
-          <a:p>
-            <a:pPr algn="ctr"/>
-            <a:r>
-              <a:rPr lang="en-AU" sz="1400" dirty="0">
-                <a:solidFill>
-                  <a:schemeClr val="tx1"/>
-                </a:solidFill>
-              </a:rPr>
-              <a:t>Application</a:t>
-            </a:r>
-            <a:endParaRPr lang="en-US" sz="1400" dirty="0">
-              <a:solidFill>
-                <a:schemeClr val="tx1"/>
-              </a:solidFill>
-            </a:endParaRPr>
-          </a:p>
-        </p:txBody>
-      </p:sp>
-      <p:sp>
-        <p:nvSpPr>
-          <p:cNvPr id="68" name="Rectangle: Rounded Corners 67">
-            <a:extLst>
-              <a:ext uri="{FF2B5EF4-FFF2-40B4-BE49-F238E27FC236}">
-                <a16:creationId xmlns:a16="http://schemas.microsoft.com/office/drawing/2014/main" id="{8DA47CAB-1028-4D11-BDCA-3953B50F9B18}"/>
-              </a:ext>
-            </a:extLst>
-          </p:cNvPr>
-          <p:cNvSpPr/>
-          <p:nvPr/>
-        </p:nvSpPr>
-        <p:spPr>
-          <a:xfrm>
-            <a:off x="7223679" y="5537590"/>
-            <a:ext cx="1220394" cy="392906"/>
-          </a:xfrm>
-          <a:prstGeom prst="roundRect">
-            <a:avLst/>
-          </a:prstGeom>
-          <a:solidFill>
-            <a:schemeClr val="accent1">
-              <a:alpha val="21000"/>
-            </a:schemeClr>
-          </a:solidFill>
-        </p:spPr>
-        <p:style>
-          <a:lnRef idx="2">
-            <a:schemeClr val="accent1">
-              <a:shade val="15000"/>
-            </a:schemeClr>
-          </a:lnRef>
-          <a:fillRef idx="1">
-            <a:schemeClr val="accent1"/>
-          </a:fillRef>
-          <a:effectRef idx="0">
-            <a:schemeClr val="accent1"/>
-          </a:effectRef>
-          <a:fontRef idx="minor">
-            <a:schemeClr val="lt1"/>
-          </a:fontRef>
-        </p:style>
-        <p:txBody>
-          <a:bodyPr rtlCol="0" anchor="ctr"/>
-          <a:lstStyle/>
-          <a:p>
-            <a:pPr algn="ctr"/>
-            <a:r>
-              <a:rPr lang="en-AU" sz="1400" dirty="0">
-                <a:solidFill>
-                  <a:schemeClr val="tx1"/>
-                </a:solidFill>
-              </a:rPr>
-              <a:t>Role</a:t>
-            </a:r>
-            <a:endParaRPr lang="en-US" sz="1400" dirty="0">
-              <a:solidFill>
-                <a:schemeClr val="tx1"/>
-              </a:solidFill>
-            </a:endParaRPr>
-          </a:p>
-        </p:txBody>
-      </p:sp>
-    </p:spTree>
-    <p:extLst>
-      <p:ext uri="{BB962C8B-B14F-4D97-AF65-F5344CB8AC3E}">
-        <p14:creationId xmlns:p14="http://schemas.microsoft.com/office/powerpoint/2010/main" val="4033068262"/>
-      </p:ext>
-    </p:extLst>
-  </p:cSld>
-  <p:clrMapOvr>
-    <a:masterClrMapping/>
-  </p:clrMapOvr>
-</p:sld>
-</file>
-
-<file path=ppt/slides/slide20.xml><?xml version="1.0" encoding="utf-8"?>
+<file path=ppt/slides/slide21.xml><?xml version="1.0" encoding="utf-8"?>
 <p:sld xmlns:a="http://schemas.openxmlformats.org/drawingml/2006/main" xmlns:r="http://schemas.openxmlformats.org/officeDocument/2006/relationships" xmlns:p="http://schemas.openxmlformats.org/presentationml/2006/main">
   <p:cSld>
     <p:spTree>
@@ -9249,7 +9538,7 @@
 </p:sld>
 </file>
 
-<file path=ppt/slides/slide21.xml><?xml version="1.0" encoding="utf-8"?>
+<file path=ppt/slides/slide22.xml><?xml version="1.0" encoding="utf-8"?>
 <p:sld xmlns:a="http://schemas.openxmlformats.org/drawingml/2006/main" xmlns:r="http://schemas.openxmlformats.org/officeDocument/2006/relationships" xmlns:p="http://schemas.openxmlformats.org/presentationml/2006/main">
   <p:cSld>
     <p:spTree>
@@ -9549,7 +9838,7 @@
 </p:sld>
 </file>
 
-<file path=ppt/slides/slide22.xml><?xml version="1.0" encoding="utf-8"?>
+<file path=ppt/slides/slide23.xml><?xml version="1.0" encoding="utf-8"?>
 <p:sld xmlns:a="http://schemas.openxmlformats.org/drawingml/2006/main" xmlns:r="http://schemas.openxmlformats.org/officeDocument/2006/relationships" xmlns:p="http://schemas.openxmlformats.org/presentationml/2006/main">
   <p:cSld>
     <p:spTree>
@@ -9785,7 +10074,7 @@
 </p:sld>
 </file>
 
-<file path=ppt/slides/slide23.xml><?xml version="1.0" encoding="utf-8"?>
+<file path=ppt/slides/slide24.xml><?xml version="1.0" encoding="utf-8"?>
 <p:sld xmlns:a="http://schemas.openxmlformats.org/drawingml/2006/main" xmlns:r="http://schemas.openxmlformats.org/officeDocument/2006/relationships" xmlns:p="http://schemas.openxmlformats.org/presentationml/2006/main">
   <p:cSld>
     <p:spTree>
@@ -10017,7 +10306,7 @@
 </p:sld>
 </file>
 
-<file path=ppt/slides/slide24.xml><?xml version="1.0" encoding="utf-8"?>
+<file path=ppt/slides/slide25.xml><?xml version="1.0" encoding="utf-8"?>
 <p:sld xmlns:a="http://schemas.openxmlformats.org/drawingml/2006/main" xmlns:r="http://schemas.openxmlformats.org/officeDocument/2006/relationships" xmlns:p="http://schemas.openxmlformats.org/presentationml/2006/main">
   <p:cSld>
     <p:spTree>
@@ -11299,7 +11588,7 @@
 </p:sld>
 </file>
 
-<file path=ppt/slides/slide25.xml><?xml version="1.0" encoding="utf-8"?>
+<file path=ppt/slides/slide26.xml><?xml version="1.0" encoding="utf-8"?>
 <p:sld xmlns:a="http://schemas.openxmlformats.org/drawingml/2006/main" xmlns:r="http://schemas.openxmlformats.org/officeDocument/2006/relationships" xmlns:p="http://schemas.openxmlformats.org/presentationml/2006/main">
   <p:cSld>
     <p:spTree>
@@ -12357,7 +12646,7 @@
 </p:sld>
 </file>
 
-<file path=ppt/slides/slide26.xml><?xml version="1.0" encoding="utf-8"?>
+<file path=ppt/slides/slide27.xml><?xml version="1.0" encoding="utf-8"?>
 <p:sld xmlns:a="http://schemas.openxmlformats.org/drawingml/2006/main" xmlns:r="http://schemas.openxmlformats.org/officeDocument/2006/relationships" xmlns:p="http://schemas.openxmlformats.org/presentationml/2006/main">
   <p:cSld>
     <p:spTree>
@@ -12887,7 +13176,7 @@
 </p:sld>
 </file>
 
-<file path=ppt/slides/slide27.xml><?xml version="1.0" encoding="utf-8"?>
+<file path=ppt/slides/slide28.xml><?xml version="1.0" encoding="utf-8"?>
 <p:sld xmlns:a="http://schemas.openxmlformats.org/drawingml/2006/main" xmlns:r="http://schemas.openxmlformats.org/officeDocument/2006/relationships" xmlns:p="http://schemas.openxmlformats.org/presentationml/2006/main">
   <p:cSld>
     <p:spTree>
@@ -13116,7 +13405,7 @@
 </p:sld>
 </file>
 
-<file path=ppt/slides/slide28.xml><?xml version="1.0" encoding="utf-8"?>
+<file path=ppt/slides/slide29.xml><?xml version="1.0" encoding="utf-8"?>
 <p:sld xmlns:a="http://schemas.openxmlformats.org/drawingml/2006/main" xmlns:r="http://schemas.openxmlformats.org/officeDocument/2006/relationships" xmlns:p="http://schemas.openxmlformats.org/presentationml/2006/main">
   <p:cSld>
     <p:spTree>
@@ -13807,553 +14096,6 @@
     <p:extLst>
       <p:ext uri="{BB962C8B-B14F-4D97-AF65-F5344CB8AC3E}">
         <p14:creationId xmlns:p14="http://schemas.microsoft.com/office/powerpoint/2010/main" val="2679877128"/>
-      </p:ext>
-    </p:extLst>
-  </p:cSld>
-  <p:clrMapOvr>
-    <a:masterClrMapping/>
-  </p:clrMapOvr>
-</p:sld>
-</file>
-
-<file path=ppt/slides/slide29.xml><?xml version="1.0" encoding="utf-8"?>
-<p:sld xmlns:a="http://schemas.openxmlformats.org/drawingml/2006/main" xmlns:r="http://schemas.openxmlformats.org/officeDocument/2006/relationships" xmlns:p="http://schemas.openxmlformats.org/presentationml/2006/main">
-  <p:cSld>
-    <p:spTree>
-      <p:nvGrpSpPr>
-        <p:cNvPr id="1" name=""/>
-        <p:cNvGrpSpPr/>
-        <p:nvPr/>
-      </p:nvGrpSpPr>
-      <p:grpSpPr>
-        <a:xfrm>
-          <a:off x="0" y="0"/>
-          <a:ext cx="0" cy="0"/>
-          <a:chOff x="0" y="0"/>
-          <a:chExt cx="0" cy="0"/>
-        </a:xfrm>
-      </p:grpSpPr>
-      <p:sp>
-        <p:nvSpPr>
-          <p:cNvPr id="3" name="TextBox 2">
-            <a:extLst>
-              <a:ext uri="{FF2B5EF4-FFF2-40B4-BE49-F238E27FC236}">
-                <a16:creationId xmlns:a16="http://schemas.microsoft.com/office/drawing/2014/main" id="{E4F0DAC2-F734-BEF2-3254-C576A1A30E65}"/>
-              </a:ext>
-            </a:extLst>
-          </p:cNvPr>
-          <p:cNvSpPr txBox="1"/>
-          <p:nvPr/>
-        </p:nvSpPr>
-        <p:spPr>
-          <a:xfrm>
-            <a:off x="601580" y="-83458"/>
-            <a:ext cx="10840452" cy="8586966"/>
-          </a:xfrm>
-          <a:prstGeom prst="rect">
-            <a:avLst/>
-          </a:prstGeom>
-          <a:noFill/>
-        </p:spPr>
-        <p:txBody>
-          <a:bodyPr wrap="square">
-            <a:spAutoFit/>
-          </a:bodyPr>
-          <a:lstStyle/>
-          <a:p>
-            <a:r>
-              <a:rPr lang="en-US" sz="1200" dirty="0"/>
-              <a:t>using </a:t>
-            </a:r>
-            <a:r>
-              <a:rPr lang="en-US" sz="1200" dirty="0" err="1"/>
-              <a:t>Microsoft.AspNetCore.Authentication.JwtBearer</a:t>
-            </a:r>
-            <a:r>
-              <a:rPr lang="en-US" sz="1200" dirty="0"/>
-              <a:t>;</a:t>
-            </a:r>
-          </a:p>
-          <a:p>
-            <a:r>
-              <a:rPr lang="en-US" sz="1200" dirty="0"/>
-              <a:t>using </a:t>
-            </a:r>
-            <a:r>
-              <a:rPr lang="en-US" sz="1200" dirty="0" err="1"/>
-              <a:t>Microsoft.IdentityModel.Tokens</a:t>
-            </a:r>
-            <a:r>
-              <a:rPr lang="en-US" sz="1200" dirty="0"/>
-              <a:t>;</a:t>
-            </a:r>
-          </a:p>
-          <a:p>
-            <a:r>
-              <a:rPr lang="en-US" sz="1200" dirty="0"/>
-              <a:t>using </a:t>
-            </a:r>
-            <a:r>
-              <a:rPr lang="en-US" sz="1200" dirty="0" err="1"/>
-              <a:t>System.Text</a:t>
-            </a:r>
-            <a:r>
-              <a:rPr lang="en-US" sz="1200" dirty="0"/>
-              <a:t>;</a:t>
-            </a:r>
-          </a:p>
-          <a:p>
-            <a:endParaRPr lang="en-US" sz="1200" dirty="0"/>
-          </a:p>
-          <a:p>
-            <a:r>
-              <a:rPr lang="en-US" sz="1200" dirty="0"/>
-              <a:t>var builder = </a:t>
-            </a:r>
-            <a:r>
-              <a:rPr lang="en-US" sz="1200" dirty="0" err="1"/>
-              <a:t>WebApplication.CreateBuilder</a:t>
-            </a:r>
-            <a:r>
-              <a:rPr lang="en-US" sz="1200" dirty="0"/>
-              <a:t>(</a:t>
-            </a:r>
-            <a:r>
-              <a:rPr lang="en-US" sz="1200" dirty="0" err="1"/>
-              <a:t>args</a:t>
-            </a:r>
-            <a:r>
-              <a:rPr lang="en-US" sz="1200" dirty="0"/>
-              <a:t>);</a:t>
-            </a:r>
-          </a:p>
-          <a:p>
-            <a:endParaRPr lang="en-US" sz="1200" dirty="0"/>
-          </a:p>
-          <a:p>
-            <a:r>
-              <a:rPr lang="en-US" sz="1200" dirty="0"/>
-              <a:t>// Add Caching</a:t>
-            </a:r>
-          </a:p>
-          <a:p>
-            <a:r>
-              <a:rPr lang="en-US" sz="1200" dirty="0" err="1"/>
-              <a:t>builder.Services.AddMemoryCache</a:t>
-            </a:r>
-            <a:r>
-              <a:rPr lang="en-US" sz="1200" dirty="0"/>
-              <a:t>();</a:t>
-            </a:r>
-          </a:p>
-          <a:p>
-            <a:endParaRPr lang="en-US" sz="1200" dirty="0"/>
-          </a:p>
-          <a:p>
-            <a:r>
-              <a:rPr lang="en-US" sz="1200" dirty="0"/>
-              <a:t>// Register our Hydration Service</a:t>
-            </a:r>
-          </a:p>
-          <a:p>
-            <a:r>
-              <a:rPr lang="en-US" sz="1200" dirty="0" err="1"/>
-              <a:t>builder.Services.AddScoped</a:t>
-            </a:r>
-            <a:r>
-              <a:rPr lang="en-US" sz="1200" dirty="0"/>
-              <a:t>&lt;</a:t>
-            </a:r>
-            <a:r>
-              <a:rPr lang="en-US" sz="1200" dirty="0" err="1"/>
-              <a:t>IClaimsTransformation</a:t>
-            </a:r>
-            <a:r>
-              <a:rPr lang="en-US" sz="1200" dirty="0"/>
-              <a:t>, </a:t>
-            </a:r>
-            <a:r>
-              <a:rPr lang="en-US" sz="1200" dirty="0" err="1"/>
-              <a:t>TenantPermissionTransformer</a:t>
-            </a:r>
-            <a:r>
-              <a:rPr lang="en-US" sz="1200" dirty="0"/>
-              <a:t>&gt;();</a:t>
-            </a:r>
-          </a:p>
-          <a:p>
-            <a:endParaRPr lang="en-US" sz="1200" dirty="0"/>
-          </a:p>
-          <a:p>
-            <a:r>
-              <a:rPr lang="en-US" sz="1200" dirty="0" err="1"/>
-              <a:t>builder.Services.AddAuthentication</a:t>
-            </a:r>
-            <a:r>
-              <a:rPr lang="en-US" sz="1200" dirty="0"/>
-              <a:t>(</a:t>
-            </a:r>
-            <a:r>
-              <a:rPr lang="en-US" sz="1200" dirty="0" err="1"/>
-              <a:t>JwtBearerDefaults.AuthenticationScheme</a:t>
-            </a:r>
-            <a:r>
-              <a:rPr lang="en-US" sz="1200" dirty="0"/>
-              <a:t>)</a:t>
-            </a:r>
-          </a:p>
-          <a:p>
-            <a:r>
-              <a:rPr lang="en-US" sz="1200" dirty="0"/>
-              <a:t>    .</a:t>
-            </a:r>
-            <a:r>
-              <a:rPr lang="en-US" sz="1200" dirty="0" err="1"/>
-              <a:t>AddJwtBearer</a:t>
-            </a:r>
-            <a:r>
-              <a:rPr lang="en-US" sz="1200" dirty="0"/>
-              <a:t>(options =&gt;</a:t>
-            </a:r>
-          </a:p>
-          <a:p>
-            <a:r>
-              <a:rPr lang="en-US" sz="1200" dirty="0"/>
-              <a:t>    {</a:t>
-            </a:r>
-          </a:p>
-          <a:p>
-            <a:r>
-              <a:rPr lang="en-US" sz="1200" dirty="0"/>
-              <a:t>        </a:t>
-            </a:r>
-            <a:r>
-              <a:rPr lang="en-US" sz="1200" dirty="0" err="1"/>
-              <a:t>options.TokenValidationParameters</a:t>
-            </a:r>
-            <a:r>
-              <a:rPr lang="en-US" sz="1200" dirty="0"/>
-              <a:t> = new </a:t>
-            </a:r>
-            <a:r>
-              <a:rPr lang="en-US" sz="1200" dirty="0" err="1"/>
-              <a:t>TokenValidationParameters</a:t>
-            </a:r>
-            <a:endParaRPr lang="en-US" sz="1200" dirty="0"/>
-          </a:p>
-          <a:p>
-            <a:r>
-              <a:rPr lang="en-US" sz="1200" dirty="0"/>
-              <a:t>        {</a:t>
-            </a:r>
-          </a:p>
-          <a:p>
-            <a:r>
-              <a:rPr lang="en-US" sz="1200" dirty="0"/>
-              <a:t>            </a:t>
-            </a:r>
-            <a:r>
-              <a:rPr lang="en-US" sz="1200" dirty="0" err="1"/>
-              <a:t>ValidateIssuer</a:t>
-            </a:r>
-            <a:r>
-              <a:rPr lang="en-US" sz="1200" dirty="0"/>
-              <a:t> = true,</a:t>
-            </a:r>
-          </a:p>
-          <a:p>
-            <a:r>
-              <a:rPr lang="en-US" sz="1200" dirty="0"/>
-              <a:t>            </a:t>
-            </a:r>
-            <a:r>
-              <a:rPr lang="en-US" sz="1200" dirty="0" err="1"/>
-              <a:t>ValidIssuer</a:t>
-            </a:r>
-            <a:r>
-              <a:rPr lang="en-US" sz="1200" dirty="0"/>
-              <a:t> = "your-app-name",</a:t>
-            </a:r>
-          </a:p>
-          <a:p>
-            <a:r>
-              <a:rPr lang="en-US" sz="1200" dirty="0"/>
-              <a:t>            </a:t>
-            </a:r>
-            <a:r>
-              <a:rPr lang="en-US" sz="1200" dirty="0" err="1"/>
-              <a:t>ValidateAudience</a:t>
-            </a:r>
-            <a:r>
-              <a:rPr lang="en-US" sz="1200" dirty="0"/>
-              <a:t> = true,</a:t>
-            </a:r>
-          </a:p>
-          <a:p>
-            <a:r>
-              <a:rPr lang="en-US" sz="1200" dirty="0"/>
-              <a:t>            </a:t>
-            </a:r>
-            <a:r>
-              <a:rPr lang="en-US" sz="1200" dirty="0" err="1"/>
-              <a:t>ValidAudience</a:t>
-            </a:r>
-            <a:r>
-              <a:rPr lang="en-US" sz="1200" dirty="0"/>
-              <a:t> = "your-spa-client",</a:t>
-            </a:r>
-          </a:p>
-          <a:p>
-            <a:r>
-              <a:rPr lang="en-US" sz="1200" dirty="0"/>
-              <a:t>            </a:t>
-            </a:r>
-            <a:r>
-              <a:rPr lang="en-US" sz="1200" dirty="0" err="1"/>
-              <a:t>ValidateLifetime</a:t>
-            </a:r>
-            <a:r>
-              <a:rPr lang="en-US" sz="1200" dirty="0"/>
-              <a:t> = true,</a:t>
-            </a:r>
-          </a:p>
-          <a:p>
-            <a:r>
-              <a:rPr lang="en-US" sz="1200" dirty="0"/>
-              <a:t>            </a:t>
-            </a:r>
-            <a:r>
-              <a:rPr lang="en-US" sz="1200" dirty="0" err="1"/>
-              <a:t>IssuerSigningKey</a:t>
-            </a:r>
-            <a:r>
-              <a:rPr lang="en-US" sz="1200" dirty="0"/>
-              <a:t> = new </a:t>
-            </a:r>
-            <a:r>
-              <a:rPr lang="en-US" sz="1200" dirty="0" err="1"/>
-              <a:t>SymmetricSecurityKey</a:t>
-            </a:r>
-            <a:r>
-              <a:rPr lang="en-US" sz="1200" dirty="0"/>
-              <a:t>(</a:t>
-            </a:r>
-          </a:p>
-          <a:p>
-            <a:r>
-              <a:rPr lang="en-US" sz="1200" dirty="0"/>
-              <a:t>                Encoding.UTF8.GetBytes("YourSuperSecretKey_MustBeAtLeast32Chars!")),</a:t>
-            </a:r>
-          </a:p>
-          <a:p>
-            <a:r>
-              <a:rPr lang="en-US" sz="1200" dirty="0"/>
-              <a:t>            </a:t>
-            </a:r>
-            <a:r>
-              <a:rPr lang="en-US" sz="1200" dirty="0" err="1"/>
-              <a:t>ClockSkew</a:t>
-            </a:r>
-            <a:r>
-              <a:rPr lang="en-US" sz="1200" dirty="0"/>
-              <a:t> = </a:t>
-            </a:r>
-            <a:r>
-              <a:rPr lang="en-US" sz="1200" dirty="0" err="1"/>
-              <a:t>TimeSpan.Zero</a:t>
-            </a:r>
-            <a:endParaRPr lang="en-US" sz="1200" dirty="0"/>
-          </a:p>
-          <a:p>
-            <a:r>
-              <a:rPr lang="en-US" sz="1200" dirty="0"/>
-              <a:t>        };</a:t>
-            </a:r>
-          </a:p>
-          <a:p>
-            <a:endParaRPr lang="en-US" sz="1200" dirty="0"/>
-          </a:p>
-          <a:p>
-            <a:r>
-              <a:rPr lang="en-US" sz="1200" dirty="0"/>
-              <a:t>        // If the SPA sends the token in a COOKIE instead of a Header:</a:t>
-            </a:r>
-          </a:p>
-          <a:p>
-            <a:r>
-              <a:rPr lang="en-US" sz="1200" dirty="0"/>
-              <a:t>        </a:t>
-            </a:r>
-            <a:r>
-              <a:rPr lang="en-US" sz="1200" dirty="0" err="1"/>
-              <a:t>options.Events</a:t>
-            </a:r>
-            <a:r>
-              <a:rPr lang="en-US" sz="1200" dirty="0"/>
-              <a:t> = new </a:t>
-            </a:r>
-            <a:r>
-              <a:rPr lang="en-US" sz="1200" dirty="0" err="1"/>
-              <a:t>JwtBearerEvents</a:t>
-            </a:r>
-            <a:endParaRPr lang="en-US" sz="1200" dirty="0"/>
-          </a:p>
-          <a:p>
-            <a:r>
-              <a:rPr lang="en-US" sz="1200" dirty="0"/>
-              <a:t>        {</a:t>
-            </a:r>
-          </a:p>
-          <a:p>
-            <a:r>
-              <a:rPr lang="en-US" sz="1200" dirty="0"/>
-              <a:t>            </a:t>
-            </a:r>
-            <a:r>
-              <a:rPr lang="en-US" sz="1200" dirty="0" err="1"/>
-              <a:t>OnMessageReceived</a:t>
-            </a:r>
-            <a:r>
-              <a:rPr lang="en-US" sz="1200" dirty="0"/>
-              <a:t> = context =&gt;</a:t>
-            </a:r>
-          </a:p>
-          <a:p>
-            <a:r>
-              <a:rPr lang="en-US" sz="1200" dirty="0"/>
-              <a:t>            {</a:t>
-            </a:r>
-          </a:p>
-          <a:p>
-            <a:r>
-              <a:rPr lang="en-US" sz="1200" dirty="0"/>
-              <a:t>                </a:t>
-            </a:r>
-            <a:r>
-              <a:rPr lang="en-US" sz="1200" dirty="0" err="1"/>
-              <a:t>context.Token</a:t>
-            </a:r>
-            <a:r>
-              <a:rPr lang="en-US" sz="1200" dirty="0"/>
-              <a:t> = </a:t>
-            </a:r>
-            <a:r>
-              <a:rPr lang="en-US" sz="1200" dirty="0" err="1"/>
-              <a:t>context.Request.Cookies</a:t>
-            </a:r>
-            <a:r>
-              <a:rPr lang="en-US" sz="1200" dirty="0"/>
-              <a:t>["</a:t>
-            </a:r>
-            <a:r>
-              <a:rPr lang="en-US" sz="1200" dirty="0" err="1"/>
-              <a:t>UserTenantToken</a:t>
-            </a:r>
-            <a:r>
-              <a:rPr lang="en-US" sz="1200" dirty="0"/>
-              <a:t>"];</a:t>
-            </a:r>
-          </a:p>
-          <a:p>
-            <a:r>
-              <a:rPr lang="en-US" sz="1200" dirty="0"/>
-              <a:t>                return </a:t>
-            </a:r>
-            <a:r>
-              <a:rPr lang="en-US" sz="1200" dirty="0" err="1"/>
-              <a:t>Task.CompletedTask</a:t>
-            </a:r>
-            <a:r>
-              <a:rPr lang="en-US" sz="1200" dirty="0"/>
-              <a:t>;</a:t>
-            </a:r>
-          </a:p>
-          <a:p>
-            <a:r>
-              <a:rPr lang="en-US" sz="1200" dirty="0"/>
-              <a:t>            }</a:t>
-            </a:r>
-          </a:p>
-          <a:p>
-            <a:r>
-              <a:rPr lang="en-US" sz="1200" dirty="0"/>
-              <a:t>        };</a:t>
-            </a:r>
-          </a:p>
-          <a:p>
-            <a:r>
-              <a:rPr lang="en-US" sz="1200" dirty="0"/>
-              <a:t>    });</a:t>
-            </a:r>
-          </a:p>
-          <a:p>
-            <a:endParaRPr lang="en-US" sz="1200" dirty="0"/>
-          </a:p>
-          <a:p>
-            <a:r>
-              <a:rPr lang="en-US" sz="1200" dirty="0" err="1"/>
-              <a:t>builder.Services.AddAuthorization</a:t>
-            </a:r>
-            <a:r>
-              <a:rPr lang="en-US" sz="1200" dirty="0"/>
-              <a:t>();</a:t>
-            </a:r>
-          </a:p>
-          <a:p>
-            <a:endParaRPr lang="en-US" sz="1200" dirty="0"/>
-          </a:p>
-          <a:p>
-            <a:r>
-              <a:rPr lang="en-US" sz="1200" dirty="0"/>
-              <a:t>var app = </a:t>
-            </a:r>
-            <a:r>
-              <a:rPr lang="en-US" sz="1200" dirty="0" err="1"/>
-              <a:t>builder.Build</a:t>
-            </a:r>
-            <a:r>
-              <a:rPr lang="en-US" sz="1200" dirty="0"/>
-              <a:t>();</a:t>
-            </a:r>
-          </a:p>
-          <a:p>
-            <a:endParaRPr lang="en-US" sz="1200" dirty="0"/>
-          </a:p>
-          <a:p>
-            <a:r>
-              <a:rPr lang="en-US" sz="1200" dirty="0" err="1"/>
-              <a:t>app.UseAuthentication</a:t>
-            </a:r>
-            <a:r>
-              <a:rPr lang="en-US" sz="1200" dirty="0"/>
-              <a:t>();</a:t>
-            </a:r>
-          </a:p>
-          <a:p>
-            <a:r>
-              <a:rPr lang="en-US" sz="1200" dirty="0" err="1"/>
-              <a:t>app.UseAuthorization</a:t>
-            </a:r>
-            <a:r>
-              <a:rPr lang="en-US" sz="1200" dirty="0"/>
-              <a:t>();</a:t>
-            </a:r>
-          </a:p>
-          <a:p>
-            <a:endParaRPr lang="en-US" sz="1200" dirty="0"/>
-          </a:p>
-          <a:p>
-            <a:r>
-              <a:rPr lang="en-US" sz="1200" dirty="0"/>
-              <a:t>// ... rest of your pipeline</a:t>
-            </a:r>
-          </a:p>
-        </p:txBody>
-      </p:sp>
-    </p:spTree>
-    <p:extLst>
-      <p:ext uri="{BB962C8B-B14F-4D97-AF65-F5344CB8AC3E}">
-        <p14:creationId xmlns:p14="http://schemas.microsoft.com/office/powerpoint/2010/main" val="3353363485"/>
       </p:ext>
     </p:extLst>
   </p:cSld>
@@ -14772,6 +14514,553 @@
 </file>
 
 <file path=ppt/slides/slide30.xml><?xml version="1.0" encoding="utf-8"?>
+<p:sld xmlns:a="http://schemas.openxmlformats.org/drawingml/2006/main" xmlns:r="http://schemas.openxmlformats.org/officeDocument/2006/relationships" xmlns:p="http://schemas.openxmlformats.org/presentationml/2006/main">
+  <p:cSld>
+    <p:spTree>
+      <p:nvGrpSpPr>
+        <p:cNvPr id="1" name=""/>
+        <p:cNvGrpSpPr/>
+        <p:nvPr/>
+      </p:nvGrpSpPr>
+      <p:grpSpPr>
+        <a:xfrm>
+          <a:off x="0" y="0"/>
+          <a:ext cx="0" cy="0"/>
+          <a:chOff x="0" y="0"/>
+          <a:chExt cx="0" cy="0"/>
+        </a:xfrm>
+      </p:grpSpPr>
+      <p:sp>
+        <p:nvSpPr>
+          <p:cNvPr id="3" name="TextBox 2">
+            <a:extLst>
+              <a:ext uri="{FF2B5EF4-FFF2-40B4-BE49-F238E27FC236}">
+                <a16:creationId xmlns:a16="http://schemas.microsoft.com/office/drawing/2014/main" id="{E4F0DAC2-F734-BEF2-3254-C576A1A30E65}"/>
+              </a:ext>
+            </a:extLst>
+          </p:cNvPr>
+          <p:cNvSpPr txBox="1"/>
+          <p:nvPr/>
+        </p:nvSpPr>
+        <p:spPr>
+          <a:xfrm>
+            <a:off x="601580" y="-83458"/>
+            <a:ext cx="10840452" cy="8586966"/>
+          </a:xfrm>
+          <a:prstGeom prst="rect">
+            <a:avLst/>
+          </a:prstGeom>
+          <a:noFill/>
+        </p:spPr>
+        <p:txBody>
+          <a:bodyPr wrap="square">
+            <a:spAutoFit/>
+          </a:bodyPr>
+          <a:lstStyle/>
+          <a:p>
+            <a:r>
+              <a:rPr lang="en-US" sz="1200" dirty="0"/>
+              <a:t>using </a:t>
+            </a:r>
+            <a:r>
+              <a:rPr lang="en-US" sz="1200" dirty="0" err="1"/>
+              <a:t>Microsoft.AspNetCore.Authentication.JwtBearer</a:t>
+            </a:r>
+            <a:r>
+              <a:rPr lang="en-US" sz="1200" dirty="0"/>
+              <a:t>;</a:t>
+            </a:r>
+          </a:p>
+          <a:p>
+            <a:r>
+              <a:rPr lang="en-US" sz="1200" dirty="0"/>
+              <a:t>using </a:t>
+            </a:r>
+            <a:r>
+              <a:rPr lang="en-US" sz="1200" dirty="0" err="1"/>
+              <a:t>Microsoft.IdentityModel.Tokens</a:t>
+            </a:r>
+            <a:r>
+              <a:rPr lang="en-US" sz="1200" dirty="0"/>
+              <a:t>;</a:t>
+            </a:r>
+          </a:p>
+          <a:p>
+            <a:r>
+              <a:rPr lang="en-US" sz="1200" dirty="0"/>
+              <a:t>using </a:t>
+            </a:r>
+            <a:r>
+              <a:rPr lang="en-US" sz="1200" dirty="0" err="1"/>
+              <a:t>System.Text</a:t>
+            </a:r>
+            <a:r>
+              <a:rPr lang="en-US" sz="1200" dirty="0"/>
+              <a:t>;</a:t>
+            </a:r>
+          </a:p>
+          <a:p>
+            <a:endParaRPr lang="en-US" sz="1200" dirty="0"/>
+          </a:p>
+          <a:p>
+            <a:r>
+              <a:rPr lang="en-US" sz="1200" dirty="0"/>
+              <a:t>var builder = </a:t>
+            </a:r>
+            <a:r>
+              <a:rPr lang="en-US" sz="1200" dirty="0" err="1"/>
+              <a:t>WebApplication.CreateBuilder</a:t>
+            </a:r>
+            <a:r>
+              <a:rPr lang="en-US" sz="1200" dirty="0"/>
+              <a:t>(</a:t>
+            </a:r>
+            <a:r>
+              <a:rPr lang="en-US" sz="1200" dirty="0" err="1"/>
+              <a:t>args</a:t>
+            </a:r>
+            <a:r>
+              <a:rPr lang="en-US" sz="1200" dirty="0"/>
+              <a:t>);</a:t>
+            </a:r>
+          </a:p>
+          <a:p>
+            <a:endParaRPr lang="en-US" sz="1200" dirty="0"/>
+          </a:p>
+          <a:p>
+            <a:r>
+              <a:rPr lang="en-US" sz="1200" dirty="0"/>
+              <a:t>// Add Caching</a:t>
+            </a:r>
+          </a:p>
+          <a:p>
+            <a:r>
+              <a:rPr lang="en-US" sz="1200" dirty="0" err="1"/>
+              <a:t>builder.Services.AddMemoryCache</a:t>
+            </a:r>
+            <a:r>
+              <a:rPr lang="en-US" sz="1200" dirty="0"/>
+              <a:t>();</a:t>
+            </a:r>
+          </a:p>
+          <a:p>
+            <a:endParaRPr lang="en-US" sz="1200" dirty="0"/>
+          </a:p>
+          <a:p>
+            <a:r>
+              <a:rPr lang="en-US" sz="1200" dirty="0"/>
+              <a:t>// Register our Hydration Service</a:t>
+            </a:r>
+          </a:p>
+          <a:p>
+            <a:r>
+              <a:rPr lang="en-US" sz="1200" dirty="0" err="1"/>
+              <a:t>builder.Services.AddScoped</a:t>
+            </a:r>
+            <a:r>
+              <a:rPr lang="en-US" sz="1200" dirty="0"/>
+              <a:t>&lt;</a:t>
+            </a:r>
+            <a:r>
+              <a:rPr lang="en-US" sz="1200" dirty="0" err="1"/>
+              <a:t>IClaimsTransformation</a:t>
+            </a:r>
+            <a:r>
+              <a:rPr lang="en-US" sz="1200" dirty="0"/>
+              <a:t>, </a:t>
+            </a:r>
+            <a:r>
+              <a:rPr lang="en-US" sz="1200" dirty="0" err="1"/>
+              <a:t>TenantPermissionTransformer</a:t>
+            </a:r>
+            <a:r>
+              <a:rPr lang="en-US" sz="1200" dirty="0"/>
+              <a:t>&gt;();</a:t>
+            </a:r>
+          </a:p>
+          <a:p>
+            <a:endParaRPr lang="en-US" sz="1200" dirty="0"/>
+          </a:p>
+          <a:p>
+            <a:r>
+              <a:rPr lang="en-US" sz="1200" dirty="0" err="1"/>
+              <a:t>builder.Services.AddAuthentication</a:t>
+            </a:r>
+            <a:r>
+              <a:rPr lang="en-US" sz="1200" dirty="0"/>
+              <a:t>(</a:t>
+            </a:r>
+            <a:r>
+              <a:rPr lang="en-US" sz="1200" dirty="0" err="1"/>
+              <a:t>JwtBearerDefaults.AuthenticationScheme</a:t>
+            </a:r>
+            <a:r>
+              <a:rPr lang="en-US" sz="1200" dirty="0"/>
+              <a:t>)</a:t>
+            </a:r>
+          </a:p>
+          <a:p>
+            <a:r>
+              <a:rPr lang="en-US" sz="1200" dirty="0"/>
+              <a:t>    .</a:t>
+            </a:r>
+            <a:r>
+              <a:rPr lang="en-US" sz="1200" dirty="0" err="1"/>
+              <a:t>AddJwtBearer</a:t>
+            </a:r>
+            <a:r>
+              <a:rPr lang="en-US" sz="1200" dirty="0"/>
+              <a:t>(options =&gt;</a:t>
+            </a:r>
+          </a:p>
+          <a:p>
+            <a:r>
+              <a:rPr lang="en-US" sz="1200" dirty="0"/>
+              <a:t>    {</a:t>
+            </a:r>
+          </a:p>
+          <a:p>
+            <a:r>
+              <a:rPr lang="en-US" sz="1200" dirty="0"/>
+              <a:t>        </a:t>
+            </a:r>
+            <a:r>
+              <a:rPr lang="en-US" sz="1200" dirty="0" err="1"/>
+              <a:t>options.TokenValidationParameters</a:t>
+            </a:r>
+            <a:r>
+              <a:rPr lang="en-US" sz="1200" dirty="0"/>
+              <a:t> = new </a:t>
+            </a:r>
+            <a:r>
+              <a:rPr lang="en-US" sz="1200" dirty="0" err="1"/>
+              <a:t>TokenValidationParameters</a:t>
+            </a:r>
+            <a:endParaRPr lang="en-US" sz="1200" dirty="0"/>
+          </a:p>
+          <a:p>
+            <a:r>
+              <a:rPr lang="en-US" sz="1200" dirty="0"/>
+              <a:t>        {</a:t>
+            </a:r>
+          </a:p>
+          <a:p>
+            <a:r>
+              <a:rPr lang="en-US" sz="1200" dirty="0"/>
+              <a:t>            </a:t>
+            </a:r>
+            <a:r>
+              <a:rPr lang="en-US" sz="1200" dirty="0" err="1"/>
+              <a:t>ValidateIssuer</a:t>
+            </a:r>
+            <a:r>
+              <a:rPr lang="en-US" sz="1200" dirty="0"/>
+              <a:t> = true,</a:t>
+            </a:r>
+          </a:p>
+          <a:p>
+            <a:r>
+              <a:rPr lang="en-US" sz="1200" dirty="0"/>
+              <a:t>            </a:t>
+            </a:r>
+            <a:r>
+              <a:rPr lang="en-US" sz="1200" dirty="0" err="1"/>
+              <a:t>ValidIssuer</a:t>
+            </a:r>
+            <a:r>
+              <a:rPr lang="en-US" sz="1200" dirty="0"/>
+              <a:t> = "your-app-name",</a:t>
+            </a:r>
+          </a:p>
+          <a:p>
+            <a:r>
+              <a:rPr lang="en-US" sz="1200" dirty="0"/>
+              <a:t>            </a:t>
+            </a:r>
+            <a:r>
+              <a:rPr lang="en-US" sz="1200" dirty="0" err="1"/>
+              <a:t>ValidateAudience</a:t>
+            </a:r>
+            <a:r>
+              <a:rPr lang="en-US" sz="1200" dirty="0"/>
+              <a:t> = true,</a:t>
+            </a:r>
+          </a:p>
+          <a:p>
+            <a:r>
+              <a:rPr lang="en-US" sz="1200" dirty="0"/>
+              <a:t>            </a:t>
+            </a:r>
+            <a:r>
+              <a:rPr lang="en-US" sz="1200" dirty="0" err="1"/>
+              <a:t>ValidAudience</a:t>
+            </a:r>
+            <a:r>
+              <a:rPr lang="en-US" sz="1200" dirty="0"/>
+              <a:t> = "your-spa-client",</a:t>
+            </a:r>
+          </a:p>
+          <a:p>
+            <a:r>
+              <a:rPr lang="en-US" sz="1200" dirty="0"/>
+              <a:t>            </a:t>
+            </a:r>
+            <a:r>
+              <a:rPr lang="en-US" sz="1200" dirty="0" err="1"/>
+              <a:t>ValidateLifetime</a:t>
+            </a:r>
+            <a:r>
+              <a:rPr lang="en-US" sz="1200" dirty="0"/>
+              <a:t> = true,</a:t>
+            </a:r>
+          </a:p>
+          <a:p>
+            <a:r>
+              <a:rPr lang="en-US" sz="1200" dirty="0"/>
+              <a:t>            </a:t>
+            </a:r>
+            <a:r>
+              <a:rPr lang="en-US" sz="1200" dirty="0" err="1"/>
+              <a:t>IssuerSigningKey</a:t>
+            </a:r>
+            <a:r>
+              <a:rPr lang="en-US" sz="1200" dirty="0"/>
+              <a:t> = new </a:t>
+            </a:r>
+            <a:r>
+              <a:rPr lang="en-US" sz="1200" dirty="0" err="1"/>
+              <a:t>SymmetricSecurityKey</a:t>
+            </a:r>
+            <a:r>
+              <a:rPr lang="en-US" sz="1200" dirty="0"/>
+              <a:t>(</a:t>
+            </a:r>
+          </a:p>
+          <a:p>
+            <a:r>
+              <a:rPr lang="en-US" sz="1200" dirty="0"/>
+              <a:t>                Encoding.UTF8.GetBytes("YourSuperSecretKey_MustBeAtLeast32Chars!")),</a:t>
+            </a:r>
+          </a:p>
+          <a:p>
+            <a:r>
+              <a:rPr lang="en-US" sz="1200" dirty="0"/>
+              <a:t>            </a:t>
+            </a:r>
+            <a:r>
+              <a:rPr lang="en-US" sz="1200" dirty="0" err="1"/>
+              <a:t>ClockSkew</a:t>
+            </a:r>
+            <a:r>
+              <a:rPr lang="en-US" sz="1200" dirty="0"/>
+              <a:t> = </a:t>
+            </a:r>
+            <a:r>
+              <a:rPr lang="en-US" sz="1200" dirty="0" err="1"/>
+              <a:t>TimeSpan.Zero</a:t>
+            </a:r>
+            <a:endParaRPr lang="en-US" sz="1200" dirty="0"/>
+          </a:p>
+          <a:p>
+            <a:r>
+              <a:rPr lang="en-US" sz="1200" dirty="0"/>
+              <a:t>        };</a:t>
+            </a:r>
+          </a:p>
+          <a:p>
+            <a:endParaRPr lang="en-US" sz="1200" dirty="0"/>
+          </a:p>
+          <a:p>
+            <a:r>
+              <a:rPr lang="en-US" sz="1200" dirty="0"/>
+              <a:t>        // If the SPA sends the token in a COOKIE instead of a Header:</a:t>
+            </a:r>
+          </a:p>
+          <a:p>
+            <a:r>
+              <a:rPr lang="en-US" sz="1200" dirty="0"/>
+              <a:t>        </a:t>
+            </a:r>
+            <a:r>
+              <a:rPr lang="en-US" sz="1200" dirty="0" err="1"/>
+              <a:t>options.Events</a:t>
+            </a:r>
+            <a:r>
+              <a:rPr lang="en-US" sz="1200" dirty="0"/>
+              <a:t> = new </a:t>
+            </a:r>
+            <a:r>
+              <a:rPr lang="en-US" sz="1200" dirty="0" err="1"/>
+              <a:t>JwtBearerEvents</a:t>
+            </a:r>
+            <a:endParaRPr lang="en-US" sz="1200" dirty="0"/>
+          </a:p>
+          <a:p>
+            <a:r>
+              <a:rPr lang="en-US" sz="1200" dirty="0"/>
+              <a:t>        {</a:t>
+            </a:r>
+          </a:p>
+          <a:p>
+            <a:r>
+              <a:rPr lang="en-US" sz="1200" dirty="0"/>
+              <a:t>            </a:t>
+            </a:r>
+            <a:r>
+              <a:rPr lang="en-US" sz="1200" dirty="0" err="1"/>
+              <a:t>OnMessageReceived</a:t>
+            </a:r>
+            <a:r>
+              <a:rPr lang="en-US" sz="1200" dirty="0"/>
+              <a:t> = context =&gt;</a:t>
+            </a:r>
+          </a:p>
+          <a:p>
+            <a:r>
+              <a:rPr lang="en-US" sz="1200" dirty="0"/>
+              <a:t>            {</a:t>
+            </a:r>
+          </a:p>
+          <a:p>
+            <a:r>
+              <a:rPr lang="en-US" sz="1200" dirty="0"/>
+              <a:t>                </a:t>
+            </a:r>
+            <a:r>
+              <a:rPr lang="en-US" sz="1200" dirty="0" err="1"/>
+              <a:t>context.Token</a:t>
+            </a:r>
+            <a:r>
+              <a:rPr lang="en-US" sz="1200" dirty="0"/>
+              <a:t> = </a:t>
+            </a:r>
+            <a:r>
+              <a:rPr lang="en-US" sz="1200" dirty="0" err="1"/>
+              <a:t>context.Request.Cookies</a:t>
+            </a:r>
+            <a:r>
+              <a:rPr lang="en-US" sz="1200" dirty="0"/>
+              <a:t>["</a:t>
+            </a:r>
+            <a:r>
+              <a:rPr lang="en-US" sz="1200" dirty="0" err="1"/>
+              <a:t>UserTenantToken</a:t>
+            </a:r>
+            <a:r>
+              <a:rPr lang="en-US" sz="1200" dirty="0"/>
+              <a:t>"];</a:t>
+            </a:r>
+          </a:p>
+          <a:p>
+            <a:r>
+              <a:rPr lang="en-US" sz="1200" dirty="0"/>
+              <a:t>                return </a:t>
+            </a:r>
+            <a:r>
+              <a:rPr lang="en-US" sz="1200" dirty="0" err="1"/>
+              <a:t>Task.CompletedTask</a:t>
+            </a:r>
+            <a:r>
+              <a:rPr lang="en-US" sz="1200" dirty="0"/>
+              <a:t>;</a:t>
+            </a:r>
+          </a:p>
+          <a:p>
+            <a:r>
+              <a:rPr lang="en-US" sz="1200" dirty="0"/>
+              <a:t>            }</a:t>
+            </a:r>
+          </a:p>
+          <a:p>
+            <a:r>
+              <a:rPr lang="en-US" sz="1200" dirty="0"/>
+              <a:t>        };</a:t>
+            </a:r>
+          </a:p>
+          <a:p>
+            <a:r>
+              <a:rPr lang="en-US" sz="1200" dirty="0"/>
+              <a:t>    });</a:t>
+            </a:r>
+          </a:p>
+          <a:p>
+            <a:endParaRPr lang="en-US" sz="1200" dirty="0"/>
+          </a:p>
+          <a:p>
+            <a:r>
+              <a:rPr lang="en-US" sz="1200" dirty="0" err="1"/>
+              <a:t>builder.Services.AddAuthorization</a:t>
+            </a:r>
+            <a:r>
+              <a:rPr lang="en-US" sz="1200" dirty="0"/>
+              <a:t>();</a:t>
+            </a:r>
+          </a:p>
+          <a:p>
+            <a:endParaRPr lang="en-US" sz="1200" dirty="0"/>
+          </a:p>
+          <a:p>
+            <a:r>
+              <a:rPr lang="en-US" sz="1200" dirty="0"/>
+              <a:t>var app = </a:t>
+            </a:r>
+            <a:r>
+              <a:rPr lang="en-US" sz="1200" dirty="0" err="1"/>
+              <a:t>builder.Build</a:t>
+            </a:r>
+            <a:r>
+              <a:rPr lang="en-US" sz="1200" dirty="0"/>
+              <a:t>();</a:t>
+            </a:r>
+          </a:p>
+          <a:p>
+            <a:endParaRPr lang="en-US" sz="1200" dirty="0"/>
+          </a:p>
+          <a:p>
+            <a:r>
+              <a:rPr lang="en-US" sz="1200" dirty="0" err="1"/>
+              <a:t>app.UseAuthentication</a:t>
+            </a:r>
+            <a:r>
+              <a:rPr lang="en-US" sz="1200" dirty="0"/>
+              <a:t>();</a:t>
+            </a:r>
+          </a:p>
+          <a:p>
+            <a:r>
+              <a:rPr lang="en-US" sz="1200" dirty="0" err="1"/>
+              <a:t>app.UseAuthorization</a:t>
+            </a:r>
+            <a:r>
+              <a:rPr lang="en-US" sz="1200" dirty="0"/>
+              <a:t>();</a:t>
+            </a:r>
+          </a:p>
+          <a:p>
+            <a:endParaRPr lang="en-US" sz="1200" dirty="0"/>
+          </a:p>
+          <a:p>
+            <a:r>
+              <a:rPr lang="en-US" sz="1200" dirty="0"/>
+              <a:t>// ... rest of your pipeline</a:t>
+            </a:r>
+          </a:p>
+        </p:txBody>
+      </p:sp>
+    </p:spTree>
+    <p:extLst>
+      <p:ext uri="{BB962C8B-B14F-4D97-AF65-F5344CB8AC3E}">
+        <p14:creationId xmlns:p14="http://schemas.microsoft.com/office/powerpoint/2010/main" val="3353363485"/>
+      </p:ext>
+    </p:extLst>
+  </p:cSld>
+  <p:clrMapOvr>
+    <a:masterClrMapping/>
+  </p:clrMapOvr>
+</p:sld>
+</file>
+
+<file path=ppt/slides/slide31.xml><?xml version="1.0" encoding="utf-8"?>
 <p:sld xmlns:a="http://schemas.openxmlformats.org/drawingml/2006/main" xmlns:r="http://schemas.openxmlformats.org/officeDocument/2006/relationships" xmlns:p="http://schemas.openxmlformats.org/presentationml/2006/main">
   <p:cSld>
     <p:spTree>
@@ -16578,7 +16867,7 @@
 </p:sld>
 </file>
 
-<file path=ppt/slides/slide31.xml><?xml version="1.0" encoding="utf-8"?>
+<file path=ppt/slides/slide32.xml><?xml version="1.0" encoding="utf-8"?>
 <p:sld xmlns:a="http://schemas.openxmlformats.org/drawingml/2006/main" xmlns:r="http://schemas.openxmlformats.org/officeDocument/2006/relationships" xmlns:p="http://schemas.openxmlformats.org/presentationml/2006/main">
   <p:cSld>
     <p:spTree>
@@ -18147,7 +18436,7 @@
 </p:sld>
 </file>
 
-<file path=ppt/slides/slide32.xml><?xml version="1.0" encoding="utf-8"?>
+<file path=ppt/slides/slide33.xml><?xml version="1.0" encoding="utf-8"?>
 <p:sld xmlns:a="http://schemas.openxmlformats.org/drawingml/2006/main" xmlns:r="http://schemas.openxmlformats.org/officeDocument/2006/relationships" xmlns:p="http://schemas.openxmlformats.org/presentationml/2006/main">
   <p:cSld>
     <p:spTree>
@@ -19277,7 +19566,7 @@
 </p:sld>
 </file>
 
-<file path=ppt/slides/slide33.xml><?xml version="1.0" encoding="utf-8"?>
+<file path=ppt/slides/slide34.xml><?xml version="1.0" encoding="utf-8"?>
 <p:sld xmlns:a="http://schemas.openxmlformats.org/drawingml/2006/main" xmlns:r="http://schemas.openxmlformats.org/officeDocument/2006/relationships" xmlns:p="http://schemas.openxmlformats.org/presentationml/2006/main">
   <p:cSld>
     <p:spTree>
@@ -20755,7 +21044,7 @@
 </p:sld>
 </file>
 
-<file path=ppt/slides/slide34.xml><?xml version="1.0" encoding="utf-8"?>
+<file path=ppt/slides/slide35.xml><?xml version="1.0" encoding="utf-8"?>
 <p:sld xmlns:a="http://schemas.openxmlformats.org/drawingml/2006/main" xmlns:r="http://schemas.openxmlformats.org/officeDocument/2006/relationships" xmlns:p="http://schemas.openxmlformats.org/presentationml/2006/main">
   <p:cSld>
     <p:spTree>
@@ -21283,7 +21572,7 @@
 </p:sld>
 </file>
 
-<file path=ppt/slides/slide35.xml><?xml version="1.0" encoding="utf-8"?>
+<file path=ppt/slides/slide36.xml><?xml version="1.0" encoding="utf-8"?>
 <p:sld xmlns:a="http://schemas.openxmlformats.org/drawingml/2006/main" xmlns:r="http://schemas.openxmlformats.org/officeDocument/2006/relationships" xmlns:p="http://schemas.openxmlformats.org/presentationml/2006/main">
   <p:cSld>
     <p:spTree>
@@ -22144,7 +22433,7 @@
 </p:sld>
 </file>
 
-<file path=ppt/slides/slide36.xml><?xml version="1.0" encoding="utf-8"?>
+<file path=ppt/slides/slide37.xml><?xml version="1.0" encoding="utf-8"?>
 <p:sld xmlns:a="http://schemas.openxmlformats.org/drawingml/2006/main" xmlns:r="http://schemas.openxmlformats.org/officeDocument/2006/relationships" xmlns:p="http://schemas.openxmlformats.org/presentationml/2006/main">
   <p:cSld>
     <p:spTree>
@@ -22471,7 +22760,7 @@
 </p:sld>
 </file>
 
-<file path=ppt/slides/slide37.xml><?xml version="1.0" encoding="utf-8"?>
+<file path=ppt/slides/slide38.xml><?xml version="1.0" encoding="utf-8"?>
 <p:sld xmlns:a="http://schemas.openxmlformats.org/drawingml/2006/main" xmlns:r="http://schemas.openxmlformats.org/officeDocument/2006/relationships" xmlns:p="http://schemas.openxmlformats.org/presentationml/2006/main">
   <p:cSld>
     <p:spTree>

</xml_diff>